<commit_message>
add the book link to Amazon
</commit_message>
<xml_diff>
--- a/PPTs/Ch1_Introduction_to_Digital_Forensics.pptx
+++ b/PPTs/Ch1_Introduction_to_Digital_Forensics.pptx
@@ -159,6 +159,83 @@
 <file path=ppt/changesInfos/changesInfo1.xml><?xml version="1.0" encoding="utf-8"?>
 <pc:chgInfo xmlns:a="http://schemas.openxmlformats.org/drawingml/2006/main" xmlns:r="http://schemas.openxmlformats.org/officeDocument/2006/relationships" xmlns:ac="http://schemas.microsoft.com/office/drawing/2013/main/command" xmlns:pc="http://schemas.microsoft.com/office/powerpoint/2013/main/command">
   <pc:docChgLst>
+    <pc:chgData name="Weifeng Xu" userId="e7aed605-a3dd-4d5a-a692-a87037af107b" providerId="ADAL" clId="{F5E39DD8-02D2-467F-8A59-B65F864F6561}"/>
+    <pc:docChg chg="custSel addSld delSld modSld sldOrd">
+      <pc:chgData name="Weifeng Xu" userId="e7aed605-a3dd-4d5a-a692-a87037af107b" providerId="ADAL" clId="{F5E39DD8-02D2-467F-8A59-B65F864F6561}" dt="2025-02-12T16:42:45.528" v="349" actId="20577"/>
+      <pc:docMkLst>
+        <pc:docMk/>
+      </pc:docMkLst>
+      <pc:sldChg chg="modSp mod">
+        <pc:chgData name="Weifeng Xu" userId="e7aed605-a3dd-4d5a-a692-a87037af107b" providerId="ADAL" clId="{F5E39DD8-02D2-467F-8A59-B65F864F6561}" dt="2025-02-12T16:36:34.201" v="31" actId="21"/>
+        <pc:sldMkLst>
+          <pc:docMk/>
+          <pc:sldMk cId="591311306" sldId="372"/>
+        </pc:sldMkLst>
+        <pc:spChg chg="mod">
+          <ac:chgData name="Weifeng Xu" userId="e7aed605-a3dd-4d5a-a692-a87037af107b" providerId="ADAL" clId="{F5E39DD8-02D2-467F-8A59-B65F864F6561}" dt="2025-02-12T16:36:34.201" v="31" actId="21"/>
+          <ac:spMkLst>
+            <pc:docMk/>
+            <pc:sldMk cId="591311306" sldId="372"/>
+            <ac:spMk id="3" creationId="{00000000-0000-0000-0000-000000000000}"/>
+          </ac:spMkLst>
+        </pc:spChg>
+      </pc:sldChg>
+      <pc:sldChg chg="del">
+        <pc:chgData name="Weifeng Xu" userId="e7aed605-a3dd-4d5a-a692-a87037af107b" providerId="ADAL" clId="{F5E39DD8-02D2-467F-8A59-B65F864F6561}" dt="2025-02-12T16:41:43.788" v="292" actId="47"/>
+        <pc:sldMkLst>
+          <pc:docMk/>
+          <pc:sldMk cId="2776652354" sldId="388"/>
+        </pc:sldMkLst>
+      </pc:sldChg>
+      <pc:sldChg chg="modSp add mod ord">
+        <pc:chgData name="Weifeng Xu" userId="e7aed605-a3dd-4d5a-a692-a87037af107b" providerId="ADAL" clId="{F5E39DD8-02D2-467F-8A59-B65F864F6561}" dt="2025-02-12T16:42:45.528" v="349" actId="20577"/>
+        <pc:sldMkLst>
+          <pc:docMk/>
+          <pc:sldMk cId="332893432" sldId="389"/>
+        </pc:sldMkLst>
+        <pc:spChg chg="mod">
+          <ac:chgData name="Weifeng Xu" userId="e7aed605-a3dd-4d5a-a692-a87037af107b" providerId="ADAL" clId="{F5E39DD8-02D2-467F-8A59-B65F864F6561}" dt="2025-02-12T16:42:45.528" v="349" actId="20577"/>
+          <ac:spMkLst>
+            <pc:docMk/>
+            <pc:sldMk cId="332893432" sldId="389"/>
+            <ac:spMk id="2" creationId="{F2F5478C-B9EB-45D5-86FE-31965B3F1F45}"/>
+          </ac:spMkLst>
+        </pc:spChg>
+        <pc:spChg chg="mod">
+          <ac:chgData name="Weifeng Xu" userId="e7aed605-a3dd-4d5a-a692-a87037af107b" providerId="ADAL" clId="{F5E39DD8-02D2-467F-8A59-B65F864F6561}" dt="2025-02-12T16:42:24.945" v="338" actId="20577"/>
+          <ac:spMkLst>
+            <pc:docMk/>
+            <pc:sldMk cId="332893432" sldId="389"/>
+            <ac:spMk id="7" creationId="{B200A21C-FD21-4EE4-BAD3-4E1E0000DF71}"/>
+          </ac:spMkLst>
+        </pc:spChg>
+      </pc:sldChg>
+      <pc:sldChg chg="addSp modSp new mod modClrScheme chgLayout">
+        <pc:chgData name="Weifeng Xu" userId="e7aed605-a3dd-4d5a-a692-a87037af107b" providerId="ADAL" clId="{F5E39DD8-02D2-467F-8A59-B65F864F6561}" dt="2025-02-12T16:41:09.319" v="291" actId="20577"/>
+        <pc:sldMkLst>
+          <pc:docMk/>
+          <pc:sldMk cId="1955666227" sldId="390"/>
+        </pc:sldMkLst>
+        <pc:spChg chg="mod ord">
+          <ac:chgData name="Weifeng Xu" userId="e7aed605-a3dd-4d5a-a692-a87037af107b" providerId="ADAL" clId="{F5E39DD8-02D2-467F-8A59-B65F864F6561}" dt="2025-02-12T16:37:25.936" v="43" actId="700"/>
+          <ac:spMkLst>
+            <pc:docMk/>
+            <pc:sldMk cId="1955666227" sldId="390"/>
+            <ac:spMk id="2" creationId="{813DB1E8-2B5C-372C-DEBA-59AC46922830}"/>
+          </ac:spMkLst>
+        </pc:spChg>
+        <pc:spChg chg="add mod ord">
+          <ac:chgData name="Weifeng Xu" userId="e7aed605-a3dd-4d5a-a692-a87037af107b" providerId="ADAL" clId="{F5E39DD8-02D2-467F-8A59-B65F864F6561}" dt="2025-02-12T16:41:09.319" v="291" actId="20577"/>
+          <ac:spMkLst>
+            <pc:docMk/>
+            <pc:sldMk cId="1955666227" sldId="390"/>
+            <ac:spMk id="3" creationId="{0A991CCD-CC74-690C-E01B-0D4C2A100A63}"/>
+          </ac:spMkLst>
+        </pc:spChg>
+      </pc:sldChg>
+    </pc:docChg>
+  </pc:docChgLst>
+  <pc:docChgLst>
     <pc:chgData name="Weifeng Xu" userId="e7aed605-a3dd-4d5a-a692-a87037af107b" providerId="ADAL" clId="{8442418D-DE68-4B3B-96F3-F4D7267D1273}"/>
     <pc:docChg chg="undo custSel addSld delSld modSld sldOrd">
       <pc:chgData name="Weifeng Xu" userId="e7aed605-a3dd-4d5a-a692-a87037af107b" providerId="ADAL" clId="{8442418D-DE68-4B3B-96F3-F4D7267D1273}" dt="2022-10-03T12:39:13.073" v="1197" actId="20577"/>
@@ -737,6 +814,575 @@
     </pc:docChg>
   </pc:docChgLst>
   <pc:docChgLst>
+    <pc:chgData name="Weifeng Xu" userId="e7aed605-a3dd-4d5a-a692-a87037af107b" providerId="ADAL" clId="{5B9B619E-E5DC-4376-BCE8-41ABC28F6C2F}"/>
+    <pc:docChg chg="addSld delSld modSld">
+      <pc:chgData name="Weifeng Xu" userId="e7aed605-a3dd-4d5a-a692-a87037af107b" providerId="ADAL" clId="{5B9B619E-E5DC-4376-BCE8-41ABC28F6C2F}" dt="2021-07-01T14:18:37.659" v="55" actId="6549"/>
+      <pc:docMkLst>
+        <pc:docMk/>
+      </pc:docMkLst>
+      <pc:sldChg chg="modSp mod">
+        <pc:chgData name="Weifeng Xu" userId="e7aed605-a3dd-4d5a-a692-a87037af107b" providerId="ADAL" clId="{5B9B619E-E5DC-4376-BCE8-41ABC28F6C2F}" dt="2021-06-28T19:38:19.716" v="0"/>
+        <pc:sldMkLst>
+          <pc:docMk/>
+          <pc:sldMk cId="1325061211" sldId="256"/>
+        </pc:sldMkLst>
+      </pc:sldChg>
+      <pc:sldChg chg="add">
+        <pc:chgData name="Weifeng Xu" userId="e7aed605-a3dd-4d5a-a692-a87037af107b" providerId="ADAL" clId="{5B9B619E-E5DC-4376-BCE8-41ABC28F6C2F}" dt="2021-06-28T19:39:54.424" v="1"/>
+        <pc:sldMkLst>
+          <pc:docMk/>
+          <pc:sldMk cId="2616338024" sldId="373"/>
+        </pc:sldMkLst>
+      </pc:sldChg>
+      <pc:sldChg chg="del">
+        <pc:chgData name="Weifeng Xu" userId="e7aed605-a3dd-4d5a-a692-a87037af107b" providerId="ADAL" clId="{5B9B619E-E5DC-4376-BCE8-41ABC28F6C2F}" dt="2021-06-28T19:40:23.201" v="12" actId="47"/>
+        <pc:sldMkLst>
+          <pc:docMk/>
+          <pc:sldMk cId="2789471632" sldId="392"/>
+        </pc:sldMkLst>
+      </pc:sldChg>
+      <pc:sldChg chg="del">
+        <pc:chgData name="Weifeng Xu" userId="e7aed605-a3dd-4d5a-a692-a87037af107b" providerId="ADAL" clId="{5B9B619E-E5DC-4376-BCE8-41ABC28F6C2F}" dt="2021-06-28T19:40:28.988" v="22" actId="47"/>
+        <pc:sldMkLst>
+          <pc:docMk/>
+          <pc:sldMk cId="2467691949" sldId="394"/>
+        </pc:sldMkLst>
+      </pc:sldChg>
+      <pc:sldChg chg="del">
+        <pc:chgData name="Weifeng Xu" userId="e7aed605-a3dd-4d5a-a692-a87037af107b" providerId="ADAL" clId="{5B9B619E-E5DC-4376-BCE8-41ABC28F6C2F}" dt="2021-06-28T19:40:29.667" v="26" actId="47"/>
+        <pc:sldMkLst>
+          <pc:docMk/>
+          <pc:sldMk cId="1635951812" sldId="396"/>
+        </pc:sldMkLst>
+      </pc:sldChg>
+      <pc:sldChg chg="del">
+        <pc:chgData name="Weifeng Xu" userId="e7aed605-a3dd-4d5a-a692-a87037af107b" providerId="ADAL" clId="{5B9B619E-E5DC-4376-BCE8-41ABC28F6C2F}" dt="2021-06-28T19:40:30.660" v="31" actId="47"/>
+        <pc:sldMkLst>
+          <pc:docMk/>
+          <pc:sldMk cId="3665038014" sldId="404"/>
+        </pc:sldMkLst>
+      </pc:sldChg>
+      <pc:sldChg chg="del">
+        <pc:chgData name="Weifeng Xu" userId="e7aed605-a3dd-4d5a-a692-a87037af107b" providerId="ADAL" clId="{5B9B619E-E5DC-4376-BCE8-41ABC28F6C2F}" dt="2021-06-28T19:40:32.953" v="39" actId="47"/>
+        <pc:sldMkLst>
+          <pc:docMk/>
+          <pc:sldMk cId="2489270501" sldId="411"/>
+        </pc:sldMkLst>
+      </pc:sldChg>
+      <pc:sldChg chg="del">
+        <pc:chgData name="Weifeng Xu" userId="e7aed605-a3dd-4d5a-a692-a87037af107b" providerId="ADAL" clId="{5B9B619E-E5DC-4376-BCE8-41ABC28F6C2F}" dt="2021-06-28T19:40:33.208" v="40" actId="47"/>
+        <pc:sldMkLst>
+          <pc:docMk/>
+          <pc:sldMk cId="3118374455" sldId="414"/>
+        </pc:sldMkLst>
+      </pc:sldChg>
+      <pc:sldChg chg="del">
+        <pc:chgData name="Weifeng Xu" userId="e7aed605-a3dd-4d5a-a692-a87037af107b" providerId="ADAL" clId="{5B9B619E-E5DC-4376-BCE8-41ABC28F6C2F}" dt="2021-06-28T19:40:30.420" v="30" actId="47"/>
+        <pc:sldMkLst>
+          <pc:docMk/>
+          <pc:sldMk cId="4266318337" sldId="416"/>
+        </pc:sldMkLst>
+      </pc:sldChg>
+      <pc:sldChg chg="del">
+        <pc:chgData name="Weifeng Xu" userId="e7aed605-a3dd-4d5a-a692-a87037af107b" providerId="ADAL" clId="{5B9B619E-E5DC-4376-BCE8-41ABC28F6C2F}" dt="2021-06-28T19:40:33.801" v="41" actId="47"/>
+        <pc:sldMkLst>
+          <pc:docMk/>
+          <pc:sldMk cId="4247754591" sldId="418"/>
+        </pc:sldMkLst>
+      </pc:sldChg>
+      <pc:sldChg chg="add">
+        <pc:chgData name="Weifeng Xu" userId="e7aed605-a3dd-4d5a-a692-a87037af107b" providerId="ADAL" clId="{5B9B619E-E5DC-4376-BCE8-41ABC28F6C2F}" dt="2021-06-28T19:39:54.424" v="1"/>
+        <pc:sldMkLst>
+          <pc:docMk/>
+          <pc:sldMk cId="3782016356" sldId="428"/>
+        </pc:sldMkLst>
+      </pc:sldChg>
+      <pc:sldChg chg="del">
+        <pc:chgData name="Weifeng Xu" userId="e7aed605-a3dd-4d5a-a692-a87037af107b" providerId="ADAL" clId="{5B9B619E-E5DC-4376-BCE8-41ABC28F6C2F}" dt="2021-06-28T19:40:23.068" v="11" actId="47"/>
+        <pc:sldMkLst>
+          <pc:docMk/>
+          <pc:sldMk cId="4091828154" sldId="430"/>
+        </pc:sldMkLst>
+      </pc:sldChg>
+      <pc:sldChg chg="del">
+        <pc:chgData name="Weifeng Xu" userId="e7aed605-a3dd-4d5a-a692-a87037af107b" providerId="ADAL" clId="{5B9B619E-E5DC-4376-BCE8-41ABC28F6C2F}" dt="2021-06-28T19:40:21.235" v="2" actId="47"/>
+        <pc:sldMkLst>
+          <pc:docMk/>
+          <pc:sldMk cId="593614233" sldId="431"/>
+        </pc:sldMkLst>
+      </pc:sldChg>
+      <pc:sldChg chg="del">
+        <pc:chgData name="Weifeng Xu" userId="e7aed605-a3dd-4d5a-a692-a87037af107b" providerId="ADAL" clId="{5B9B619E-E5DC-4376-BCE8-41ABC28F6C2F}" dt="2021-06-28T19:40:32.187" v="36" actId="47"/>
+        <pc:sldMkLst>
+          <pc:docMk/>
+          <pc:sldMk cId="2829655940" sldId="434"/>
+        </pc:sldMkLst>
+      </pc:sldChg>
+      <pc:sldChg chg="del">
+        <pc:chgData name="Weifeng Xu" userId="e7aed605-a3dd-4d5a-a692-a87037af107b" providerId="ADAL" clId="{5B9B619E-E5DC-4376-BCE8-41ABC28F6C2F}" dt="2021-06-28T19:40:37.137" v="49" actId="47"/>
+        <pc:sldMkLst>
+          <pc:docMk/>
+          <pc:sldMk cId="4105321355" sldId="439"/>
+        </pc:sldMkLst>
+      </pc:sldChg>
+      <pc:sldChg chg="del">
+        <pc:chgData name="Weifeng Xu" userId="e7aed605-a3dd-4d5a-a692-a87037af107b" providerId="ADAL" clId="{5B9B619E-E5DC-4376-BCE8-41ABC28F6C2F}" dt="2021-06-28T19:40:40.112" v="50" actId="47"/>
+        <pc:sldMkLst>
+          <pc:docMk/>
+          <pc:sldMk cId="1827660371" sldId="440"/>
+        </pc:sldMkLst>
+      </pc:sldChg>
+      <pc:sldChg chg="del">
+        <pc:chgData name="Weifeng Xu" userId="e7aed605-a3dd-4d5a-a692-a87037af107b" providerId="ADAL" clId="{5B9B619E-E5DC-4376-BCE8-41ABC28F6C2F}" dt="2021-06-28T19:40:41.177" v="51" actId="47"/>
+        <pc:sldMkLst>
+          <pc:docMk/>
+          <pc:sldMk cId="117761190" sldId="441"/>
+        </pc:sldMkLst>
+      </pc:sldChg>
+      <pc:sldChg chg="del">
+        <pc:chgData name="Weifeng Xu" userId="e7aed605-a3dd-4d5a-a692-a87037af107b" providerId="ADAL" clId="{5B9B619E-E5DC-4376-BCE8-41ABC28F6C2F}" dt="2021-06-28T19:40:34.634" v="43" actId="47"/>
+        <pc:sldMkLst>
+          <pc:docMk/>
+          <pc:sldMk cId="4060643725" sldId="442"/>
+        </pc:sldMkLst>
+      </pc:sldChg>
+      <pc:sldChg chg="del">
+        <pc:chgData name="Weifeng Xu" userId="e7aed605-a3dd-4d5a-a692-a87037af107b" providerId="ADAL" clId="{5B9B619E-E5DC-4376-BCE8-41ABC28F6C2F}" dt="2021-06-28T19:40:42.517" v="52" actId="47"/>
+        <pc:sldMkLst>
+          <pc:docMk/>
+          <pc:sldMk cId="177244511" sldId="443"/>
+        </pc:sldMkLst>
+      </pc:sldChg>
+      <pc:sldChg chg="modSp add mod">
+        <pc:chgData name="Weifeng Xu" userId="e7aed605-a3dd-4d5a-a692-a87037af107b" providerId="ADAL" clId="{5B9B619E-E5DC-4376-BCE8-41ABC28F6C2F}" dt="2021-07-01T14:03:43.721" v="53" actId="14100"/>
+        <pc:sldMkLst>
+          <pc:docMk/>
+          <pc:sldMk cId="969276203" sldId="444"/>
+        </pc:sldMkLst>
+      </pc:sldChg>
+      <pc:sldChg chg="add">
+        <pc:chgData name="Weifeng Xu" userId="e7aed605-a3dd-4d5a-a692-a87037af107b" providerId="ADAL" clId="{5B9B619E-E5DC-4376-BCE8-41ABC28F6C2F}" dt="2021-06-28T19:39:54.424" v="1"/>
+        <pc:sldMkLst>
+          <pc:docMk/>
+          <pc:sldMk cId="2518429501" sldId="445"/>
+        </pc:sldMkLst>
+      </pc:sldChg>
+      <pc:sldChg chg="add">
+        <pc:chgData name="Weifeng Xu" userId="e7aed605-a3dd-4d5a-a692-a87037af107b" providerId="ADAL" clId="{5B9B619E-E5DC-4376-BCE8-41ABC28F6C2F}" dt="2021-06-28T19:39:54.424" v="1"/>
+        <pc:sldMkLst>
+          <pc:docMk/>
+          <pc:sldMk cId="2089025007" sldId="446"/>
+        </pc:sldMkLst>
+      </pc:sldChg>
+      <pc:sldChg chg="del">
+        <pc:chgData name="Weifeng Xu" userId="e7aed605-a3dd-4d5a-a692-a87037af107b" providerId="ADAL" clId="{5B9B619E-E5DC-4376-BCE8-41ABC28F6C2F}" dt="2021-06-28T19:40:21.736" v="3" actId="47"/>
+        <pc:sldMkLst>
+          <pc:docMk/>
+          <pc:sldMk cId="396884143" sldId="447"/>
+        </pc:sldMkLst>
+      </pc:sldChg>
+      <pc:sldChg chg="del">
+        <pc:chgData name="Weifeng Xu" userId="e7aed605-a3dd-4d5a-a692-a87037af107b" providerId="ADAL" clId="{5B9B619E-E5DC-4376-BCE8-41ABC28F6C2F}" dt="2021-06-28T19:40:21.938" v="4" actId="47"/>
+        <pc:sldMkLst>
+          <pc:docMk/>
+          <pc:sldMk cId="2623075134" sldId="448"/>
+        </pc:sldMkLst>
+      </pc:sldChg>
+      <pc:sldChg chg="del">
+        <pc:chgData name="Weifeng Xu" userId="e7aed605-a3dd-4d5a-a692-a87037af107b" providerId="ADAL" clId="{5B9B619E-E5DC-4376-BCE8-41ABC28F6C2F}" dt="2021-06-28T19:40:22.262" v="5" actId="47"/>
+        <pc:sldMkLst>
+          <pc:docMk/>
+          <pc:sldMk cId="3726437819" sldId="449"/>
+        </pc:sldMkLst>
+      </pc:sldChg>
+      <pc:sldChg chg="del">
+        <pc:chgData name="Weifeng Xu" userId="e7aed605-a3dd-4d5a-a692-a87037af107b" providerId="ADAL" clId="{5B9B619E-E5DC-4376-BCE8-41ABC28F6C2F}" dt="2021-06-28T19:40:22.449" v="7" actId="47"/>
+        <pc:sldMkLst>
+          <pc:docMk/>
+          <pc:sldMk cId="2752542596" sldId="450"/>
+        </pc:sldMkLst>
+      </pc:sldChg>
+      <pc:sldChg chg="del">
+        <pc:chgData name="Weifeng Xu" userId="e7aed605-a3dd-4d5a-a692-a87037af107b" providerId="ADAL" clId="{5B9B619E-E5DC-4376-BCE8-41ABC28F6C2F}" dt="2021-06-28T19:40:23.913" v="13" actId="47"/>
+        <pc:sldMkLst>
+          <pc:docMk/>
+          <pc:sldMk cId="1689162150" sldId="451"/>
+        </pc:sldMkLst>
+      </pc:sldChg>
+      <pc:sldChg chg="del">
+        <pc:chgData name="Weifeng Xu" userId="e7aed605-a3dd-4d5a-a692-a87037af107b" providerId="ADAL" clId="{5B9B619E-E5DC-4376-BCE8-41ABC28F6C2F}" dt="2021-06-28T19:40:24.202" v="15" actId="47"/>
+        <pc:sldMkLst>
+          <pc:docMk/>
+          <pc:sldMk cId="3213363844" sldId="452"/>
+        </pc:sldMkLst>
+      </pc:sldChg>
+      <pc:sldChg chg="add">
+        <pc:chgData name="Weifeng Xu" userId="e7aed605-a3dd-4d5a-a692-a87037af107b" providerId="ADAL" clId="{5B9B619E-E5DC-4376-BCE8-41ABC28F6C2F}" dt="2021-06-28T19:39:54.424" v="1"/>
+        <pc:sldMkLst>
+          <pc:docMk/>
+          <pc:sldMk cId="2427580819" sldId="453"/>
+        </pc:sldMkLst>
+      </pc:sldChg>
+      <pc:sldChg chg="add">
+        <pc:chgData name="Weifeng Xu" userId="e7aed605-a3dd-4d5a-a692-a87037af107b" providerId="ADAL" clId="{5B9B619E-E5DC-4376-BCE8-41ABC28F6C2F}" dt="2021-06-28T19:39:54.424" v="1"/>
+        <pc:sldMkLst>
+          <pc:docMk/>
+          <pc:sldMk cId="156228340" sldId="454"/>
+        </pc:sldMkLst>
+      </pc:sldChg>
+      <pc:sldChg chg="del">
+        <pc:chgData name="Weifeng Xu" userId="e7aed605-a3dd-4d5a-a692-a87037af107b" providerId="ADAL" clId="{5B9B619E-E5DC-4376-BCE8-41ABC28F6C2F}" dt="2021-06-28T19:40:22.776" v="9" actId="47"/>
+        <pc:sldMkLst>
+          <pc:docMk/>
+          <pc:sldMk cId="855798641" sldId="455"/>
+        </pc:sldMkLst>
+      </pc:sldChg>
+      <pc:sldChg chg="del">
+        <pc:chgData name="Weifeng Xu" userId="e7aed605-a3dd-4d5a-a692-a87037af107b" providerId="ADAL" clId="{5B9B619E-E5DC-4376-BCE8-41ABC28F6C2F}" dt="2021-06-28T19:40:22.612" v="8" actId="47"/>
+        <pc:sldMkLst>
+          <pc:docMk/>
+          <pc:sldMk cId="3068364558" sldId="456"/>
+        </pc:sldMkLst>
+      </pc:sldChg>
+      <pc:sldChg chg="del">
+        <pc:chgData name="Weifeng Xu" userId="e7aed605-a3dd-4d5a-a692-a87037af107b" providerId="ADAL" clId="{5B9B619E-E5DC-4376-BCE8-41ABC28F6C2F}" dt="2021-06-28T19:40:22.913" v="10" actId="47"/>
+        <pc:sldMkLst>
+          <pc:docMk/>
+          <pc:sldMk cId="565360195" sldId="457"/>
+        </pc:sldMkLst>
+      </pc:sldChg>
+      <pc:sldChg chg="del">
+        <pc:chgData name="Weifeng Xu" userId="e7aed605-a3dd-4d5a-a692-a87037af107b" providerId="ADAL" clId="{5B9B619E-E5DC-4376-BCE8-41ABC28F6C2F}" dt="2021-06-28T19:40:24.050" v="14" actId="47"/>
+        <pc:sldMkLst>
+          <pc:docMk/>
+          <pc:sldMk cId="2399777802" sldId="458"/>
+        </pc:sldMkLst>
+      </pc:sldChg>
+      <pc:sldChg chg="del">
+        <pc:chgData name="Weifeng Xu" userId="e7aed605-a3dd-4d5a-a692-a87037af107b" providerId="ADAL" clId="{5B9B619E-E5DC-4376-BCE8-41ABC28F6C2F}" dt="2021-06-28T19:40:28.818" v="21" actId="47"/>
+        <pc:sldMkLst>
+          <pc:docMk/>
+          <pc:sldMk cId="783190951" sldId="459"/>
+        </pc:sldMkLst>
+      </pc:sldChg>
+      <pc:sldChg chg="del">
+        <pc:chgData name="Weifeng Xu" userId="e7aed605-a3dd-4d5a-a692-a87037af107b" providerId="ADAL" clId="{5B9B619E-E5DC-4376-BCE8-41ABC28F6C2F}" dt="2021-06-28T19:40:24.505" v="17" actId="47"/>
+        <pc:sldMkLst>
+          <pc:docMk/>
+          <pc:sldMk cId="3533845808" sldId="460"/>
+        </pc:sldMkLst>
+      </pc:sldChg>
+      <pc:sldChg chg="del">
+        <pc:chgData name="Weifeng Xu" userId="e7aed605-a3dd-4d5a-a692-a87037af107b" providerId="ADAL" clId="{5B9B619E-E5DC-4376-BCE8-41ABC28F6C2F}" dt="2021-06-28T19:40:27.003" v="18" actId="47"/>
+        <pc:sldMkLst>
+          <pc:docMk/>
+          <pc:sldMk cId="982174642" sldId="461"/>
+        </pc:sldMkLst>
+      </pc:sldChg>
+      <pc:sldChg chg="del">
+        <pc:chgData name="Weifeng Xu" userId="e7aed605-a3dd-4d5a-a692-a87037af107b" providerId="ADAL" clId="{5B9B619E-E5DC-4376-BCE8-41ABC28F6C2F}" dt="2021-06-28T19:40:22.278" v="6" actId="47"/>
+        <pc:sldMkLst>
+          <pc:docMk/>
+          <pc:sldMk cId="926730047" sldId="462"/>
+        </pc:sldMkLst>
+      </pc:sldChg>
+      <pc:sldChg chg="del">
+        <pc:chgData name="Weifeng Xu" userId="e7aed605-a3dd-4d5a-a692-a87037af107b" providerId="ADAL" clId="{5B9B619E-E5DC-4376-BCE8-41ABC28F6C2F}" dt="2021-06-28T19:40:24.346" v="16" actId="47"/>
+        <pc:sldMkLst>
+          <pc:docMk/>
+          <pc:sldMk cId="2128572627" sldId="463"/>
+        </pc:sldMkLst>
+      </pc:sldChg>
+      <pc:sldChg chg="del">
+        <pc:chgData name="Weifeng Xu" userId="e7aed605-a3dd-4d5a-a692-a87037af107b" providerId="ADAL" clId="{5B9B619E-E5DC-4376-BCE8-41ABC28F6C2F}" dt="2021-06-28T19:40:29.162" v="23" actId="47"/>
+        <pc:sldMkLst>
+          <pc:docMk/>
+          <pc:sldMk cId="3901806330" sldId="464"/>
+        </pc:sldMkLst>
+      </pc:sldChg>
+      <pc:sldChg chg="del">
+        <pc:chgData name="Weifeng Xu" userId="e7aed605-a3dd-4d5a-a692-a87037af107b" providerId="ADAL" clId="{5B9B619E-E5DC-4376-BCE8-41ABC28F6C2F}" dt="2021-06-28T19:40:28.042" v="19" actId="47"/>
+        <pc:sldMkLst>
+          <pc:docMk/>
+          <pc:sldMk cId="1673180284" sldId="465"/>
+        </pc:sldMkLst>
+      </pc:sldChg>
+      <pc:sldChg chg="del">
+        <pc:chgData name="Weifeng Xu" userId="e7aed605-a3dd-4d5a-a692-a87037af107b" providerId="ADAL" clId="{5B9B619E-E5DC-4376-BCE8-41ABC28F6C2F}" dt="2021-06-28T19:40:28.602" v="20" actId="47"/>
+        <pc:sldMkLst>
+          <pc:docMk/>
+          <pc:sldMk cId="369337190" sldId="466"/>
+        </pc:sldMkLst>
+      </pc:sldChg>
+      <pc:sldChg chg="add">
+        <pc:chgData name="Weifeng Xu" userId="e7aed605-a3dd-4d5a-a692-a87037af107b" providerId="ADAL" clId="{5B9B619E-E5DC-4376-BCE8-41ABC28F6C2F}" dt="2021-06-28T19:39:54.424" v="1"/>
+        <pc:sldMkLst>
+          <pc:docMk/>
+          <pc:sldMk cId="965843776" sldId="467"/>
+        </pc:sldMkLst>
+      </pc:sldChg>
+      <pc:sldChg chg="del">
+        <pc:chgData name="Weifeng Xu" userId="e7aed605-a3dd-4d5a-a692-a87037af107b" providerId="ADAL" clId="{5B9B619E-E5DC-4376-BCE8-41ABC28F6C2F}" dt="2021-06-28T19:40:29.322" v="24" actId="47"/>
+        <pc:sldMkLst>
+          <pc:docMk/>
+          <pc:sldMk cId="1544977207" sldId="468"/>
+        </pc:sldMkLst>
+      </pc:sldChg>
+      <pc:sldChg chg="del">
+        <pc:chgData name="Weifeng Xu" userId="e7aed605-a3dd-4d5a-a692-a87037af107b" providerId="ADAL" clId="{5B9B619E-E5DC-4376-BCE8-41ABC28F6C2F}" dt="2021-06-28T19:40:29.501" v="25" actId="47"/>
+        <pc:sldMkLst>
+          <pc:docMk/>
+          <pc:sldMk cId="3247576171" sldId="469"/>
+        </pc:sldMkLst>
+      </pc:sldChg>
+      <pc:sldChg chg="del">
+        <pc:chgData name="Weifeng Xu" userId="e7aed605-a3dd-4d5a-a692-a87037af107b" providerId="ADAL" clId="{5B9B619E-E5DC-4376-BCE8-41ABC28F6C2F}" dt="2021-06-28T19:40:29.865" v="27" actId="47"/>
+        <pc:sldMkLst>
+          <pc:docMk/>
+          <pc:sldMk cId="3121458959" sldId="470"/>
+        </pc:sldMkLst>
+      </pc:sldChg>
+      <pc:sldChg chg="del">
+        <pc:chgData name="Weifeng Xu" userId="e7aed605-a3dd-4d5a-a692-a87037af107b" providerId="ADAL" clId="{5B9B619E-E5DC-4376-BCE8-41ABC28F6C2F}" dt="2021-06-28T19:40:30.254" v="28" actId="47"/>
+        <pc:sldMkLst>
+          <pc:docMk/>
+          <pc:sldMk cId="2693326884" sldId="471"/>
+        </pc:sldMkLst>
+      </pc:sldChg>
+      <pc:sldChg chg="del">
+        <pc:chgData name="Weifeng Xu" userId="e7aed605-a3dd-4d5a-a692-a87037af107b" providerId="ADAL" clId="{5B9B619E-E5DC-4376-BCE8-41ABC28F6C2F}" dt="2021-06-28T19:40:30.263" v="29" actId="47"/>
+        <pc:sldMkLst>
+          <pc:docMk/>
+          <pc:sldMk cId="127914859" sldId="472"/>
+        </pc:sldMkLst>
+      </pc:sldChg>
+      <pc:sldChg chg="del">
+        <pc:chgData name="Weifeng Xu" userId="e7aed605-a3dd-4d5a-a692-a87037af107b" providerId="ADAL" clId="{5B9B619E-E5DC-4376-BCE8-41ABC28F6C2F}" dt="2021-06-28T19:40:31.073" v="32" actId="47"/>
+        <pc:sldMkLst>
+          <pc:docMk/>
+          <pc:sldMk cId="2516623109" sldId="475"/>
+        </pc:sldMkLst>
+      </pc:sldChg>
+      <pc:sldChg chg="del">
+        <pc:chgData name="Weifeng Xu" userId="e7aed605-a3dd-4d5a-a692-a87037af107b" providerId="ADAL" clId="{5B9B619E-E5DC-4376-BCE8-41ABC28F6C2F}" dt="2021-06-28T19:40:31.393" v="33" actId="47"/>
+        <pc:sldMkLst>
+          <pc:docMk/>
+          <pc:sldMk cId="3141623341" sldId="476"/>
+        </pc:sldMkLst>
+      </pc:sldChg>
+      <pc:sldChg chg="del">
+        <pc:chgData name="Weifeng Xu" userId="e7aed605-a3dd-4d5a-a692-a87037af107b" providerId="ADAL" clId="{5B9B619E-E5DC-4376-BCE8-41ABC28F6C2F}" dt="2021-06-28T19:40:31.714" v="34" actId="47"/>
+        <pc:sldMkLst>
+          <pc:docMk/>
+          <pc:sldMk cId="4107473677" sldId="477"/>
+        </pc:sldMkLst>
+      </pc:sldChg>
+      <pc:sldChg chg="del">
+        <pc:chgData name="Weifeng Xu" userId="e7aed605-a3dd-4d5a-a692-a87037af107b" providerId="ADAL" clId="{5B9B619E-E5DC-4376-BCE8-41ABC28F6C2F}" dt="2021-06-28T19:40:31.858" v="35" actId="47"/>
+        <pc:sldMkLst>
+          <pc:docMk/>
+          <pc:sldMk cId="1773530336" sldId="478"/>
+        </pc:sldMkLst>
+      </pc:sldChg>
+      <pc:sldChg chg="del">
+        <pc:chgData name="Weifeng Xu" userId="e7aed605-a3dd-4d5a-a692-a87037af107b" providerId="ADAL" clId="{5B9B619E-E5DC-4376-BCE8-41ABC28F6C2F}" dt="2021-06-28T19:40:34.221" v="42" actId="47"/>
+        <pc:sldMkLst>
+          <pc:docMk/>
+          <pc:sldMk cId="2418320045" sldId="481"/>
+        </pc:sldMkLst>
+      </pc:sldChg>
+      <pc:sldChg chg="del">
+        <pc:chgData name="Weifeng Xu" userId="e7aed605-a3dd-4d5a-a692-a87037af107b" providerId="ADAL" clId="{5B9B619E-E5DC-4376-BCE8-41ABC28F6C2F}" dt="2021-06-28T19:40:32.426" v="37" actId="47"/>
+        <pc:sldMkLst>
+          <pc:docMk/>
+          <pc:sldMk cId="1683867025" sldId="482"/>
+        </pc:sldMkLst>
+      </pc:sldChg>
+      <pc:sldChg chg="del">
+        <pc:chgData name="Weifeng Xu" userId="e7aed605-a3dd-4d5a-a692-a87037af107b" providerId="ADAL" clId="{5B9B619E-E5DC-4376-BCE8-41ABC28F6C2F}" dt="2021-06-28T19:40:32.693" v="38" actId="47"/>
+        <pc:sldMkLst>
+          <pc:docMk/>
+          <pc:sldMk cId="3022927922" sldId="484"/>
+        </pc:sldMkLst>
+      </pc:sldChg>
+      <pc:sldChg chg="del">
+        <pc:chgData name="Weifeng Xu" userId="e7aed605-a3dd-4d5a-a692-a87037af107b" providerId="ADAL" clId="{5B9B619E-E5DC-4376-BCE8-41ABC28F6C2F}" dt="2021-06-28T19:40:34.898" v="44" actId="47"/>
+        <pc:sldMkLst>
+          <pc:docMk/>
+          <pc:sldMk cId="1979037057" sldId="485"/>
+        </pc:sldMkLst>
+      </pc:sldChg>
+      <pc:sldChg chg="del">
+        <pc:chgData name="Weifeng Xu" userId="e7aed605-a3dd-4d5a-a692-a87037af107b" providerId="ADAL" clId="{5B9B619E-E5DC-4376-BCE8-41ABC28F6C2F}" dt="2021-06-28T19:40:35.185" v="45" actId="47"/>
+        <pc:sldMkLst>
+          <pc:docMk/>
+          <pc:sldMk cId="229412847" sldId="486"/>
+        </pc:sldMkLst>
+      </pc:sldChg>
+      <pc:sldChg chg="del">
+        <pc:chgData name="Weifeng Xu" userId="e7aed605-a3dd-4d5a-a692-a87037af107b" providerId="ADAL" clId="{5B9B619E-E5DC-4376-BCE8-41ABC28F6C2F}" dt="2021-06-28T19:40:35.713" v="46" actId="47"/>
+        <pc:sldMkLst>
+          <pc:docMk/>
+          <pc:sldMk cId="127162036" sldId="487"/>
+        </pc:sldMkLst>
+      </pc:sldChg>
+      <pc:sldChg chg="del">
+        <pc:chgData name="Weifeng Xu" userId="e7aed605-a3dd-4d5a-a692-a87037af107b" providerId="ADAL" clId="{5B9B619E-E5DC-4376-BCE8-41ABC28F6C2F}" dt="2021-06-28T19:40:36.169" v="47" actId="47"/>
+        <pc:sldMkLst>
+          <pc:docMk/>
+          <pc:sldMk cId="1436574554" sldId="488"/>
+        </pc:sldMkLst>
+      </pc:sldChg>
+      <pc:sldChg chg="del">
+        <pc:chgData name="Weifeng Xu" userId="e7aed605-a3dd-4d5a-a692-a87037af107b" providerId="ADAL" clId="{5B9B619E-E5DC-4376-BCE8-41ABC28F6C2F}" dt="2021-06-28T19:40:36.576" v="48" actId="47"/>
+        <pc:sldMkLst>
+          <pc:docMk/>
+          <pc:sldMk cId="3579863255" sldId="489"/>
+        </pc:sldMkLst>
+      </pc:sldChg>
+      <pc:sldChg chg="add">
+        <pc:chgData name="Weifeng Xu" userId="e7aed605-a3dd-4d5a-a692-a87037af107b" providerId="ADAL" clId="{5B9B619E-E5DC-4376-BCE8-41ABC28F6C2F}" dt="2021-06-28T19:39:54.424" v="1"/>
+        <pc:sldMkLst>
+          <pc:docMk/>
+          <pc:sldMk cId="1435293485" sldId="490"/>
+        </pc:sldMkLst>
+      </pc:sldChg>
+      <pc:sldChg chg="add">
+        <pc:chgData name="Weifeng Xu" userId="e7aed605-a3dd-4d5a-a692-a87037af107b" providerId="ADAL" clId="{5B9B619E-E5DC-4376-BCE8-41ABC28F6C2F}" dt="2021-06-28T19:39:54.424" v="1"/>
+        <pc:sldMkLst>
+          <pc:docMk/>
+          <pc:sldMk cId="3015196105" sldId="491"/>
+        </pc:sldMkLst>
+      </pc:sldChg>
+      <pc:sldChg chg="modSp add mod">
+        <pc:chgData name="Weifeng Xu" userId="e7aed605-a3dd-4d5a-a692-a87037af107b" providerId="ADAL" clId="{5B9B619E-E5DC-4376-BCE8-41ABC28F6C2F}" dt="2021-07-01T14:18:37.659" v="55" actId="6549"/>
+        <pc:sldMkLst>
+          <pc:docMk/>
+          <pc:sldMk cId="1674251011" sldId="492"/>
+        </pc:sldMkLst>
+      </pc:sldChg>
+      <pc:sldChg chg="add">
+        <pc:chgData name="Weifeng Xu" userId="e7aed605-a3dd-4d5a-a692-a87037af107b" providerId="ADAL" clId="{5B9B619E-E5DC-4376-BCE8-41ABC28F6C2F}" dt="2021-06-28T19:39:54.424" v="1"/>
+        <pc:sldMkLst>
+          <pc:docMk/>
+          <pc:sldMk cId="2416641626" sldId="493"/>
+        </pc:sldMkLst>
+      </pc:sldChg>
+      <pc:sldChg chg="add">
+        <pc:chgData name="Weifeng Xu" userId="e7aed605-a3dd-4d5a-a692-a87037af107b" providerId="ADAL" clId="{5B9B619E-E5DC-4376-BCE8-41ABC28F6C2F}" dt="2021-06-28T19:39:54.424" v="1"/>
+        <pc:sldMkLst>
+          <pc:docMk/>
+          <pc:sldMk cId="311612657" sldId="494"/>
+        </pc:sldMkLst>
+      </pc:sldChg>
+      <pc:sldChg chg="add">
+        <pc:chgData name="Weifeng Xu" userId="e7aed605-a3dd-4d5a-a692-a87037af107b" providerId="ADAL" clId="{5B9B619E-E5DC-4376-BCE8-41ABC28F6C2F}" dt="2021-06-28T19:39:54.424" v="1"/>
+        <pc:sldMkLst>
+          <pc:docMk/>
+          <pc:sldMk cId="3933795559" sldId="495"/>
+        </pc:sldMkLst>
+      </pc:sldChg>
+      <pc:sldChg chg="add">
+        <pc:chgData name="Weifeng Xu" userId="e7aed605-a3dd-4d5a-a692-a87037af107b" providerId="ADAL" clId="{5B9B619E-E5DC-4376-BCE8-41ABC28F6C2F}" dt="2021-06-28T19:39:54.424" v="1"/>
+        <pc:sldMkLst>
+          <pc:docMk/>
+          <pc:sldMk cId="684404787" sldId="496"/>
+        </pc:sldMkLst>
+      </pc:sldChg>
+      <pc:sldChg chg="add">
+        <pc:chgData name="Weifeng Xu" userId="e7aed605-a3dd-4d5a-a692-a87037af107b" providerId="ADAL" clId="{5B9B619E-E5DC-4376-BCE8-41ABC28F6C2F}" dt="2021-06-28T19:39:54.424" v="1"/>
+        <pc:sldMkLst>
+          <pc:docMk/>
+          <pc:sldMk cId="3211001472" sldId="497"/>
+        </pc:sldMkLst>
+      </pc:sldChg>
+      <pc:sldChg chg="add">
+        <pc:chgData name="Weifeng Xu" userId="e7aed605-a3dd-4d5a-a692-a87037af107b" providerId="ADAL" clId="{5B9B619E-E5DC-4376-BCE8-41ABC28F6C2F}" dt="2021-06-28T19:39:54.424" v="1"/>
+        <pc:sldMkLst>
+          <pc:docMk/>
+          <pc:sldMk cId="1035595462" sldId="498"/>
+        </pc:sldMkLst>
+      </pc:sldChg>
+      <pc:sldChg chg="add">
+        <pc:chgData name="Weifeng Xu" userId="e7aed605-a3dd-4d5a-a692-a87037af107b" providerId="ADAL" clId="{5B9B619E-E5DC-4376-BCE8-41ABC28F6C2F}" dt="2021-06-28T19:39:54.424" v="1"/>
+        <pc:sldMkLst>
+          <pc:docMk/>
+          <pc:sldMk cId="1984385075" sldId="499"/>
+        </pc:sldMkLst>
+      </pc:sldChg>
+      <pc:sldChg chg="add">
+        <pc:chgData name="Weifeng Xu" userId="e7aed605-a3dd-4d5a-a692-a87037af107b" providerId="ADAL" clId="{5B9B619E-E5DC-4376-BCE8-41ABC28F6C2F}" dt="2021-06-28T19:39:54.424" v="1"/>
+        <pc:sldMkLst>
+          <pc:docMk/>
+          <pc:sldMk cId="3318379012" sldId="500"/>
+        </pc:sldMkLst>
+      </pc:sldChg>
+      <pc:sldChg chg="add">
+        <pc:chgData name="Weifeng Xu" userId="e7aed605-a3dd-4d5a-a692-a87037af107b" providerId="ADAL" clId="{5B9B619E-E5DC-4376-BCE8-41ABC28F6C2F}" dt="2021-06-28T19:39:54.424" v="1"/>
+        <pc:sldMkLst>
+          <pc:docMk/>
+          <pc:sldMk cId="2125122821" sldId="501"/>
+        </pc:sldMkLst>
+      </pc:sldChg>
+      <pc:sldChg chg="add">
+        <pc:chgData name="Weifeng Xu" userId="e7aed605-a3dd-4d5a-a692-a87037af107b" providerId="ADAL" clId="{5B9B619E-E5DC-4376-BCE8-41ABC28F6C2F}" dt="2021-06-28T19:39:54.424" v="1"/>
+        <pc:sldMkLst>
+          <pc:docMk/>
+          <pc:sldMk cId="198983510" sldId="502"/>
+        </pc:sldMkLst>
+      </pc:sldChg>
+      <pc:sldChg chg="add">
+        <pc:chgData name="Weifeng Xu" userId="e7aed605-a3dd-4d5a-a692-a87037af107b" providerId="ADAL" clId="{5B9B619E-E5DC-4376-BCE8-41ABC28F6C2F}" dt="2021-06-28T19:39:54.424" v="1"/>
+        <pc:sldMkLst>
+          <pc:docMk/>
+          <pc:sldMk cId="686110812" sldId="503"/>
+        </pc:sldMkLst>
+      </pc:sldChg>
+      <pc:sldChg chg="add">
+        <pc:chgData name="Weifeng Xu" userId="e7aed605-a3dd-4d5a-a692-a87037af107b" providerId="ADAL" clId="{5B9B619E-E5DC-4376-BCE8-41ABC28F6C2F}" dt="2021-06-28T19:39:54.424" v="1"/>
+        <pc:sldMkLst>
+          <pc:docMk/>
+          <pc:sldMk cId="3430879985" sldId="504"/>
+        </pc:sldMkLst>
+      </pc:sldChg>
+      <pc:sldChg chg="add">
+        <pc:chgData name="Weifeng Xu" userId="e7aed605-a3dd-4d5a-a692-a87037af107b" providerId="ADAL" clId="{5B9B619E-E5DC-4376-BCE8-41ABC28F6C2F}" dt="2021-06-28T19:39:54.424" v="1"/>
+        <pc:sldMkLst>
+          <pc:docMk/>
+          <pc:sldMk cId="1270554279" sldId="505"/>
+        </pc:sldMkLst>
+      </pc:sldChg>
+      <pc:sldChg chg="add">
+        <pc:chgData name="Weifeng Xu" userId="e7aed605-a3dd-4d5a-a692-a87037af107b" providerId="ADAL" clId="{5B9B619E-E5DC-4376-BCE8-41ABC28F6C2F}" dt="2021-06-28T19:39:54.424" v="1"/>
+        <pc:sldMkLst>
+          <pc:docMk/>
+          <pc:sldMk cId="951356934" sldId="506"/>
+        </pc:sldMkLst>
+      </pc:sldChg>
+      <pc:sldChg chg="add">
+        <pc:chgData name="Weifeng Xu" userId="e7aed605-a3dd-4d5a-a692-a87037af107b" providerId="ADAL" clId="{5B9B619E-E5DC-4376-BCE8-41ABC28F6C2F}" dt="2021-06-28T19:39:54.424" v="1"/>
+        <pc:sldMkLst>
+          <pc:docMk/>
+          <pc:sldMk cId="1385115538" sldId="507"/>
+        </pc:sldMkLst>
+      </pc:sldChg>
+      <pc:sldChg chg="add">
+        <pc:chgData name="Weifeng Xu" userId="e7aed605-a3dd-4d5a-a692-a87037af107b" providerId="ADAL" clId="{5B9B619E-E5DC-4376-BCE8-41ABC28F6C2F}" dt="2021-06-28T19:39:54.424" v="1"/>
+        <pc:sldMkLst>
+          <pc:docMk/>
+          <pc:sldMk cId="494372939" sldId="508"/>
+        </pc:sldMkLst>
+      </pc:sldChg>
+      <pc:sldChg chg="add">
+        <pc:chgData name="Weifeng Xu" userId="e7aed605-a3dd-4d5a-a692-a87037af107b" providerId="ADAL" clId="{5B9B619E-E5DC-4376-BCE8-41ABC28F6C2F}" dt="2021-06-28T19:39:54.424" v="1"/>
+        <pc:sldMkLst>
+          <pc:docMk/>
+          <pc:sldMk cId="2058254067" sldId="509"/>
+        </pc:sldMkLst>
+      </pc:sldChg>
+    </pc:docChg>
+  </pc:docChgLst>
+  <pc:docChgLst>
     <pc:chgData name="Weifeng Xu" userId="e7aed605-a3dd-4d5a-a692-a87037af107b" providerId="ADAL" clId="{2DF50834-70B7-4792-8287-7E44FACC55EB}"/>
     <pc:docChg chg="undo redo custSel addSld delSld modSld sldOrd">
       <pc:chgData name="Weifeng Xu" userId="e7aed605-a3dd-4d5a-a692-a87037af107b" providerId="ADAL" clId="{2DF50834-70B7-4792-8287-7E44FACC55EB}" dt="2021-06-27T14:32:54.680" v="2383" actId="114"/>
@@ -1147,652 +1793,6 @@
         <pc:sldMkLst>
           <pc:docMk/>
           <pc:sldMk cId="2625291343" sldId="446"/>
-        </pc:sldMkLst>
-      </pc:sldChg>
-    </pc:docChg>
-  </pc:docChgLst>
-  <pc:docChgLst>
-    <pc:chgData name="Weifeng Xu" userId="e7aed605-a3dd-4d5a-a692-a87037af107b" providerId="ADAL" clId="{F5E39DD8-02D2-467F-8A59-B65F864F6561}"/>
-    <pc:docChg chg="custSel addSld delSld modSld sldOrd">
-      <pc:chgData name="Weifeng Xu" userId="e7aed605-a3dd-4d5a-a692-a87037af107b" providerId="ADAL" clId="{F5E39DD8-02D2-467F-8A59-B65F864F6561}" dt="2025-02-12T16:42:45.528" v="349" actId="20577"/>
-      <pc:docMkLst>
-        <pc:docMk/>
-      </pc:docMkLst>
-      <pc:sldChg chg="modSp mod">
-        <pc:chgData name="Weifeng Xu" userId="e7aed605-a3dd-4d5a-a692-a87037af107b" providerId="ADAL" clId="{F5E39DD8-02D2-467F-8A59-B65F864F6561}" dt="2025-02-12T16:36:34.201" v="31" actId="21"/>
-        <pc:sldMkLst>
-          <pc:docMk/>
-          <pc:sldMk cId="591311306" sldId="372"/>
-        </pc:sldMkLst>
-        <pc:spChg chg="mod">
-          <ac:chgData name="Weifeng Xu" userId="e7aed605-a3dd-4d5a-a692-a87037af107b" providerId="ADAL" clId="{F5E39DD8-02D2-467F-8A59-B65F864F6561}" dt="2025-02-12T16:36:34.201" v="31" actId="21"/>
-          <ac:spMkLst>
-            <pc:docMk/>
-            <pc:sldMk cId="591311306" sldId="372"/>
-            <ac:spMk id="3" creationId="{00000000-0000-0000-0000-000000000000}"/>
-          </ac:spMkLst>
-        </pc:spChg>
-      </pc:sldChg>
-      <pc:sldChg chg="del">
-        <pc:chgData name="Weifeng Xu" userId="e7aed605-a3dd-4d5a-a692-a87037af107b" providerId="ADAL" clId="{F5E39DD8-02D2-467F-8A59-B65F864F6561}" dt="2025-02-12T16:41:43.788" v="292" actId="47"/>
-        <pc:sldMkLst>
-          <pc:docMk/>
-          <pc:sldMk cId="2776652354" sldId="388"/>
-        </pc:sldMkLst>
-      </pc:sldChg>
-      <pc:sldChg chg="modSp add mod ord">
-        <pc:chgData name="Weifeng Xu" userId="e7aed605-a3dd-4d5a-a692-a87037af107b" providerId="ADAL" clId="{F5E39DD8-02D2-467F-8A59-B65F864F6561}" dt="2025-02-12T16:42:45.528" v="349" actId="20577"/>
-        <pc:sldMkLst>
-          <pc:docMk/>
-          <pc:sldMk cId="332893432" sldId="389"/>
-        </pc:sldMkLst>
-        <pc:spChg chg="mod">
-          <ac:chgData name="Weifeng Xu" userId="e7aed605-a3dd-4d5a-a692-a87037af107b" providerId="ADAL" clId="{F5E39DD8-02D2-467F-8A59-B65F864F6561}" dt="2025-02-12T16:42:45.528" v="349" actId="20577"/>
-          <ac:spMkLst>
-            <pc:docMk/>
-            <pc:sldMk cId="332893432" sldId="389"/>
-            <ac:spMk id="2" creationId="{F2F5478C-B9EB-45D5-86FE-31965B3F1F45}"/>
-          </ac:spMkLst>
-        </pc:spChg>
-        <pc:spChg chg="mod">
-          <ac:chgData name="Weifeng Xu" userId="e7aed605-a3dd-4d5a-a692-a87037af107b" providerId="ADAL" clId="{F5E39DD8-02D2-467F-8A59-B65F864F6561}" dt="2025-02-12T16:42:24.945" v="338" actId="20577"/>
-          <ac:spMkLst>
-            <pc:docMk/>
-            <pc:sldMk cId="332893432" sldId="389"/>
-            <ac:spMk id="7" creationId="{B200A21C-FD21-4EE4-BAD3-4E1E0000DF71}"/>
-          </ac:spMkLst>
-        </pc:spChg>
-      </pc:sldChg>
-      <pc:sldChg chg="addSp modSp new mod modClrScheme chgLayout">
-        <pc:chgData name="Weifeng Xu" userId="e7aed605-a3dd-4d5a-a692-a87037af107b" providerId="ADAL" clId="{F5E39DD8-02D2-467F-8A59-B65F864F6561}" dt="2025-02-12T16:41:09.319" v="291" actId="20577"/>
-        <pc:sldMkLst>
-          <pc:docMk/>
-          <pc:sldMk cId="1955666227" sldId="390"/>
-        </pc:sldMkLst>
-        <pc:spChg chg="mod ord">
-          <ac:chgData name="Weifeng Xu" userId="e7aed605-a3dd-4d5a-a692-a87037af107b" providerId="ADAL" clId="{F5E39DD8-02D2-467F-8A59-B65F864F6561}" dt="2025-02-12T16:37:25.936" v="43" actId="700"/>
-          <ac:spMkLst>
-            <pc:docMk/>
-            <pc:sldMk cId="1955666227" sldId="390"/>
-            <ac:spMk id="2" creationId="{813DB1E8-2B5C-372C-DEBA-59AC46922830}"/>
-          </ac:spMkLst>
-        </pc:spChg>
-        <pc:spChg chg="add mod ord">
-          <ac:chgData name="Weifeng Xu" userId="e7aed605-a3dd-4d5a-a692-a87037af107b" providerId="ADAL" clId="{F5E39DD8-02D2-467F-8A59-B65F864F6561}" dt="2025-02-12T16:41:09.319" v="291" actId="20577"/>
-          <ac:spMkLst>
-            <pc:docMk/>
-            <pc:sldMk cId="1955666227" sldId="390"/>
-            <ac:spMk id="3" creationId="{0A991CCD-CC74-690C-E01B-0D4C2A100A63}"/>
-          </ac:spMkLst>
-        </pc:spChg>
-      </pc:sldChg>
-    </pc:docChg>
-  </pc:docChgLst>
-  <pc:docChgLst>
-    <pc:chgData name="Weifeng Xu" userId="e7aed605-a3dd-4d5a-a692-a87037af107b" providerId="ADAL" clId="{5B9B619E-E5DC-4376-BCE8-41ABC28F6C2F}"/>
-    <pc:docChg chg="addSld delSld modSld">
-      <pc:chgData name="Weifeng Xu" userId="e7aed605-a3dd-4d5a-a692-a87037af107b" providerId="ADAL" clId="{5B9B619E-E5DC-4376-BCE8-41ABC28F6C2F}" dt="2021-07-01T14:18:37.659" v="55" actId="6549"/>
-      <pc:docMkLst>
-        <pc:docMk/>
-      </pc:docMkLst>
-      <pc:sldChg chg="modSp mod">
-        <pc:chgData name="Weifeng Xu" userId="e7aed605-a3dd-4d5a-a692-a87037af107b" providerId="ADAL" clId="{5B9B619E-E5DC-4376-BCE8-41ABC28F6C2F}" dt="2021-06-28T19:38:19.716" v="0"/>
-        <pc:sldMkLst>
-          <pc:docMk/>
-          <pc:sldMk cId="1325061211" sldId="256"/>
-        </pc:sldMkLst>
-      </pc:sldChg>
-      <pc:sldChg chg="add">
-        <pc:chgData name="Weifeng Xu" userId="e7aed605-a3dd-4d5a-a692-a87037af107b" providerId="ADAL" clId="{5B9B619E-E5DC-4376-BCE8-41ABC28F6C2F}" dt="2021-06-28T19:39:54.424" v="1"/>
-        <pc:sldMkLst>
-          <pc:docMk/>
-          <pc:sldMk cId="2616338024" sldId="373"/>
-        </pc:sldMkLst>
-      </pc:sldChg>
-      <pc:sldChg chg="del">
-        <pc:chgData name="Weifeng Xu" userId="e7aed605-a3dd-4d5a-a692-a87037af107b" providerId="ADAL" clId="{5B9B619E-E5DC-4376-BCE8-41ABC28F6C2F}" dt="2021-06-28T19:40:23.201" v="12" actId="47"/>
-        <pc:sldMkLst>
-          <pc:docMk/>
-          <pc:sldMk cId="2789471632" sldId="392"/>
-        </pc:sldMkLst>
-      </pc:sldChg>
-      <pc:sldChg chg="del">
-        <pc:chgData name="Weifeng Xu" userId="e7aed605-a3dd-4d5a-a692-a87037af107b" providerId="ADAL" clId="{5B9B619E-E5DC-4376-BCE8-41ABC28F6C2F}" dt="2021-06-28T19:40:28.988" v="22" actId="47"/>
-        <pc:sldMkLst>
-          <pc:docMk/>
-          <pc:sldMk cId="2467691949" sldId="394"/>
-        </pc:sldMkLst>
-      </pc:sldChg>
-      <pc:sldChg chg="del">
-        <pc:chgData name="Weifeng Xu" userId="e7aed605-a3dd-4d5a-a692-a87037af107b" providerId="ADAL" clId="{5B9B619E-E5DC-4376-BCE8-41ABC28F6C2F}" dt="2021-06-28T19:40:29.667" v="26" actId="47"/>
-        <pc:sldMkLst>
-          <pc:docMk/>
-          <pc:sldMk cId="1635951812" sldId="396"/>
-        </pc:sldMkLst>
-      </pc:sldChg>
-      <pc:sldChg chg="del">
-        <pc:chgData name="Weifeng Xu" userId="e7aed605-a3dd-4d5a-a692-a87037af107b" providerId="ADAL" clId="{5B9B619E-E5DC-4376-BCE8-41ABC28F6C2F}" dt="2021-06-28T19:40:30.660" v="31" actId="47"/>
-        <pc:sldMkLst>
-          <pc:docMk/>
-          <pc:sldMk cId="3665038014" sldId="404"/>
-        </pc:sldMkLst>
-      </pc:sldChg>
-      <pc:sldChg chg="del">
-        <pc:chgData name="Weifeng Xu" userId="e7aed605-a3dd-4d5a-a692-a87037af107b" providerId="ADAL" clId="{5B9B619E-E5DC-4376-BCE8-41ABC28F6C2F}" dt="2021-06-28T19:40:32.953" v="39" actId="47"/>
-        <pc:sldMkLst>
-          <pc:docMk/>
-          <pc:sldMk cId="2489270501" sldId="411"/>
-        </pc:sldMkLst>
-      </pc:sldChg>
-      <pc:sldChg chg="del">
-        <pc:chgData name="Weifeng Xu" userId="e7aed605-a3dd-4d5a-a692-a87037af107b" providerId="ADAL" clId="{5B9B619E-E5DC-4376-BCE8-41ABC28F6C2F}" dt="2021-06-28T19:40:33.208" v="40" actId="47"/>
-        <pc:sldMkLst>
-          <pc:docMk/>
-          <pc:sldMk cId="3118374455" sldId="414"/>
-        </pc:sldMkLst>
-      </pc:sldChg>
-      <pc:sldChg chg="del">
-        <pc:chgData name="Weifeng Xu" userId="e7aed605-a3dd-4d5a-a692-a87037af107b" providerId="ADAL" clId="{5B9B619E-E5DC-4376-BCE8-41ABC28F6C2F}" dt="2021-06-28T19:40:30.420" v="30" actId="47"/>
-        <pc:sldMkLst>
-          <pc:docMk/>
-          <pc:sldMk cId="4266318337" sldId="416"/>
-        </pc:sldMkLst>
-      </pc:sldChg>
-      <pc:sldChg chg="del">
-        <pc:chgData name="Weifeng Xu" userId="e7aed605-a3dd-4d5a-a692-a87037af107b" providerId="ADAL" clId="{5B9B619E-E5DC-4376-BCE8-41ABC28F6C2F}" dt="2021-06-28T19:40:33.801" v="41" actId="47"/>
-        <pc:sldMkLst>
-          <pc:docMk/>
-          <pc:sldMk cId="4247754591" sldId="418"/>
-        </pc:sldMkLst>
-      </pc:sldChg>
-      <pc:sldChg chg="add">
-        <pc:chgData name="Weifeng Xu" userId="e7aed605-a3dd-4d5a-a692-a87037af107b" providerId="ADAL" clId="{5B9B619E-E5DC-4376-BCE8-41ABC28F6C2F}" dt="2021-06-28T19:39:54.424" v="1"/>
-        <pc:sldMkLst>
-          <pc:docMk/>
-          <pc:sldMk cId="3782016356" sldId="428"/>
-        </pc:sldMkLst>
-      </pc:sldChg>
-      <pc:sldChg chg="del">
-        <pc:chgData name="Weifeng Xu" userId="e7aed605-a3dd-4d5a-a692-a87037af107b" providerId="ADAL" clId="{5B9B619E-E5DC-4376-BCE8-41ABC28F6C2F}" dt="2021-06-28T19:40:23.068" v="11" actId="47"/>
-        <pc:sldMkLst>
-          <pc:docMk/>
-          <pc:sldMk cId="4091828154" sldId="430"/>
-        </pc:sldMkLst>
-      </pc:sldChg>
-      <pc:sldChg chg="del">
-        <pc:chgData name="Weifeng Xu" userId="e7aed605-a3dd-4d5a-a692-a87037af107b" providerId="ADAL" clId="{5B9B619E-E5DC-4376-BCE8-41ABC28F6C2F}" dt="2021-06-28T19:40:21.235" v="2" actId="47"/>
-        <pc:sldMkLst>
-          <pc:docMk/>
-          <pc:sldMk cId="593614233" sldId="431"/>
-        </pc:sldMkLst>
-      </pc:sldChg>
-      <pc:sldChg chg="del">
-        <pc:chgData name="Weifeng Xu" userId="e7aed605-a3dd-4d5a-a692-a87037af107b" providerId="ADAL" clId="{5B9B619E-E5DC-4376-BCE8-41ABC28F6C2F}" dt="2021-06-28T19:40:32.187" v="36" actId="47"/>
-        <pc:sldMkLst>
-          <pc:docMk/>
-          <pc:sldMk cId="2829655940" sldId="434"/>
-        </pc:sldMkLst>
-      </pc:sldChg>
-      <pc:sldChg chg="del">
-        <pc:chgData name="Weifeng Xu" userId="e7aed605-a3dd-4d5a-a692-a87037af107b" providerId="ADAL" clId="{5B9B619E-E5DC-4376-BCE8-41ABC28F6C2F}" dt="2021-06-28T19:40:37.137" v="49" actId="47"/>
-        <pc:sldMkLst>
-          <pc:docMk/>
-          <pc:sldMk cId="4105321355" sldId="439"/>
-        </pc:sldMkLst>
-      </pc:sldChg>
-      <pc:sldChg chg="del">
-        <pc:chgData name="Weifeng Xu" userId="e7aed605-a3dd-4d5a-a692-a87037af107b" providerId="ADAL" clId="{5B9B619E-E5DC-4376-BCE8-41ABC28F6C2F}" dt="2021-06-28T19:40:40.112" v="50" actId="47"/>
-        <pc:sldMkLst>
-          <pc:docMk/>
-          <pc:sldMk cId="1827660371" sldId="440"/>
-        </pc:sldMkLst>
-      </pc:sldChg>
-      <pc:sldChg chg="del">
-        <pc:chgData name="Weifeng Xu" userId="e7aed605-a3dd-4d5a-a692-a87037af107b" providerId="ADAL" clId="{5B9B619E-E5DC-4376-BCE8-41ABC28F6C2F}" dt="2021-06-28T19:40:41.177" v="51" actId="47"/>
-        <pc:sldMkLst>
-          <pc:docMk/>
-          <pc:sldMk cId="117761190" sldId="441"/>
-        </pc:sldMkLst>
-      </pc:sldChg>
-      <pc:sldChg chg="del">
-        <pc:chgData name="Weifeng Xu" userId="e7aed605-a3dd-4d5a-a692-a87037af107b" providerId="ADAL" clId="{5B9B619E-E5DC-4376-BCE8-41ABC28F6C2F}" dt="2021-06-28T19:40:34.634" v="43" actId="47"/>
-        <pc:sldMkLst>
-          <pc:docMk/>
-          <pc:sldMk cId="4060643725" sldId="442"/>
-        </pc:sldMkLst>
-      </pc:sldChg>
-      <pc:sldChg chg="del">
-        <pc:chgData name="Weifeng Xu" userId="e7aed605-a3dd-4d5a-a692-a87037af107b" providerId="ADAL" clId="{5B9B619E-E5DC-4376-BCE8-41ABC28F6C2F}" dt="2021-06-28T19:40:42.517" v="52" actId="47"/>
-        <pc:sldMkLst>
-          <pc:docMk/>
-          <pc:sldMk cId="177244511" sldId="443"/>
-        </pc:sldMkLst>
-      </pc:sldChg>
-      <pc:sldChg chg="modSp add mod">
-        <pc:chgData name="Weifeng Xu" userId="e7aed605-a3dd-4d5a-a692-a87037af107b" providerId="ADAL" clId="{5B9B619E-E5DC-4376-BCE8-41ABC28F6C2F}" dt="2021-07-01T14:03:43.721" v="53" actId="14100"/>
-        <pc:sldMkLst>
-          <pc:docMk/>
-          <pc:sldMk cId="969276203" sldId="444"/>
-        </pc:sldMkLst>
-      </pc:sldChg>
-      <pc:sldChg chg="add">
-        <pc:chgData name="Weifeng Xu" userId="e7aed605-a3dd-4d5a-a692-a87037af107b" providerId="ADAL" clId="{5B9B619E-E5DC-4376-BCE8-41ABC28F6C2F}" dt="2021-06-28T19:39:54.424" v="1"/>
-        <pc:sldMkLst>
-          <pc:docMk/>
-          <pc:sldMk cId="2518429501" sldId="445"/>
-        </pc:sldMkLst>
-      </pc:sldChg>
-      <pc:sldChg chg="add">
-        <pc:chgData name="Weifeng Xu" userId="e7aed605-a3dd-4d5a-a692-a87037af107b" providerId="ADAL" clId="{5B9B619E-E5DC-4376-BCE8-41ABC28F6C2F}" dt="2021-06-28T19:39:54.424" v="1"/>
-        <pc:sldMkLst>
-          <pc:docMk/>
-          <pc:sldMk cId="2089025007" sldId="446"/>
-        </pc:sldMkLst>
-      </pc:sldChg>
-      <pc:sldChg chg="del">
-        <pc:chgData name="Weifeng Xu" userId="e7aed605-a3dd-4d5a-a692-a87037af107b" providerId="ADAL" clId="{5B9B619E-E5DC-4376-BCE8-41ABC28F6C2F}" dt="2021-06-28T19:40:21.736" v="3" actId="47"/>
-        <pc:sldMkLst>
-          <pc:docMk/>
-          <pc:sldMk cId="396884143" sldId="447"/>
-        </pc:sldMkLst>
-      </pc:sldChg>
-      <pc:sldChg chg="del">
-        <pc:chgData name="Weifeng Xu" userId="e7aed605-a3dd-4d5a-a692-a87037af107b" providerId="ADAL" clId="{5B9B619E-E5DC-4376-BCE8-41ABC28F6C2F}" dt="2021-06-28T19:40:21.938" v="4" actId="47"/>
-        <pc:sldMkLst>
-          <pc:docMk/>
-          <pc:sldMk cId="2623075134" sldId="448"/>
-        </pc:sldMkLst>
-      </pc:sldChg>
-      <pc:sldChg chg="del">
-        <pc:chgData name="Weifeng Xu" userId="e7aed605-a3dd-4d5a-a692-a87037af107b" providerId="ADAL" clId="{5B9B619E-E5DC-4376-BCE8-41ABC28F6C2F}" dt="2021-06-28T19:40:22.262" v="5" actId="47"/>
-        <pc:sldMkLst>
-          <pc:docMk/>
-          <pc:sldMk cId="3726437819" sldId="449"/>
-        </pc:sldMkLst>
-      </pc:sldChg>
-      <pc:sldChg chg="del">
-        <pc:chgData name="Weifeng Xu" userId="e7aed605-a3dd-4d5a-a692-a87037af107b" providerId="ADAL" clId="{5B9B619E-E5DC-4376-BCE8-41ABC28F6C2F}" dt="2021-06-28T19:40:22.449" v="7" actId="47"/>
-        <pc:sldMkLst>
-          <pc:docMk/>
-          <pc:sldMk cId="2752542596" sldId="450"/>
-        </pc:sldMkLst>
-      </pc:sldChg>
-      <pc:sldChg chg="del">
-        <pc:chgData name="Weifeng Xu" userId="e7aed605-a3dd-4d5a-a692-a87037af107b" providerId="ADAL" clId="{5B9B619E-E5DC-4376-BCE8-41ABC28F6C2F}" dt="2021-06-28T19:40:23.913" v="13" actId="47"/>
-        <pc:sldMkLst>
-          <pc:docMk/>
-          <pc:sldMk cId="1689162150" sldId="451"/>
-        </pc:sldMkLst>
-      </pc:sldChg>
-      <pc:sldChg chg="del">
-        <pc:chgData name="Weifeng Xu" userId="e7aed605-a3dd-4d5a-a692-a87037af107b" providerId="ADAL" clId="{5B9B619E-E5DC-4376-BCE8-41ABC28F6C2F}" dt="2021-06-28T19:40:24.202" v="15" actId="47"/>
-        <pc:sldMkLst>
-          <pc:docMk/>
-          <pc:sldMk cId="3213363844" sldId="452"/>
-        </pc:sldMkLst>
-      </pc:sldChg>
-      <pc:sldChg chg="add">
-        <pc:chgData name="Weifeng Xu" userId="e7aed605-a3dd-4d5a-a692-a87037af107b" providerId="ADAL" clId="{5B9B619E-E5DC-4376-BCE8-41ABC28F6C2F}" dt="2021-06-28T19:39:54.424" v="1"/>
-        <pc:sldMkLst>
-          <pc:docMk/>
-          <pc:sldMk cId="2427580819" sldId="453"/>
-        </pc:sldMkLst>
-      </pc:sldChg>
-      <pc:sldChg chg="add">
-        <pc:chgData name="Weifeng Xu" userId="e7aed605-a3dd-4d5a-a692-a87037af107b" providerId="ADAL" clId="{5B9B619E-E5DC-4376-BCE8-41ABC28F6C2F}" dt="2021-06-28T19:39:54.424" v="1"/>
-        <pc:sldMkLst>
-          <pc:docMk/>
-          <pc:sldMk cId="156228340" sldId="454"/>
-        </pc:sldMkLst>
-      </pc:sldChg>
-      <pc:sldChg chg="del">
-        <pc:chgData name="Weifeng Xu" userId="e7aed605-a3dd-4d5a-a692-a87037af107b" providerId="ADAL" clId="{5B9B619E-E5DC-4376-BCE8-41ABC28F6C2F}" dt="2021-06-28T19:40:22.776" v="9" actId="47"/>
-        <pc:sldMkLst>
-          <pc:docMk/>
-          <pc:sldMk cId="855798641" sldId="455"/>
-        </pc:sldMkLst>
-      </pc:sldChg>
-      <pc:sldChg chg="del">
-        <pc:chgData name="Weifeng Xu" userId="e7aed605-a3dd-4d5a-a692-a87037af107b" providerId="ADAL" clId="{5B9B619E-E5DC-4376-BCE8-41ABC28F6C2F}" dt="2021-06-28T19:40:22.612" v="8" actId="47"/>
-        <pc:sldMkLst>
-          <pc:docMk/>
-          <pc:sldMk cId="3068364558" sldId="456"/>
-        </pc:sldMkLst>
-      </pc:sldChg>
-      <pc:sldChg chg="del">
-        <pc:chgData name="Weifeng Xu" userId="e7aed605-a3dd-4d5a-a692-a87037af107b" providerId="ADAL" clId="{5B9B619E-E5DC-4376-BCE8-41ABC28F6C2F}" dt="2021-06-28T19:40:22.913" v="10" actId="47"/>
-        <pc:sldMkLst>
-          <pc:docMk/>
-          <pc:sldMk cId="565360195" sldId="457"/>
-        </pc:sldMkLst>
-      </pc:sldChg>
-      <pc:sldChg chg="del">
-        <pc:chgData name="Weifeng Xu" userId="e7aed605-a3dd-4d5a-a692-a87037af107b" providerId="ADAL" clId="{5B9B619E-E5DC-4376-BCE8-41ABC28F6C2F}" dt="2021-06-28T19:40:24.050" v="14" actId="47"/>
-        <pc:sldMkLst>
-          <pc:docMk/>
-          <pc:sldMk cId="2399777802" sldId="458"/>
-        </pc:sldMkLst>
-      </pc:sldChg>
-      <pc:sldChg chg="del">
-        <pc:chgData name="Weifeng Xu" userId="e7aed605-a3dd-4d5a-a692-a87037af107b" providerId="ADAL" clId="{5B9B619E-E5DC-4376-BCE8-41ABC28F6C2F}" dt="2021-06-28T19:40:28.818" v="21" actId="47"/>
-        <pc:sldMkLst>
-          <pc:docMk/>
-          <pc:sldMk cId="783190951" sldId="459"/>
-        </pc:sldMkLst>
-      </pc:sldChg>
-      <pc:sldChg chg="del">
-        <pc:chgData name="Weifeng Xu" userId="e7aed605-a3dd-4d5a-a692-a87037af107b" providerId="ADAL" clId="{5B9B619E-E5DC-4376-BCE8-41ABC28F6C2F}" dt="2021-06-28T19:40:24.505" v="17" actId="47"/>
-        <pc:sldMkLst>
-          <pc:docMk/>
-          <pc:sldMk cId="3533845808" sldId="460"/>
-        </pc:sldMkLst>
-      </pc:sldChg>
-      <pc:sldChg chg="del">
-        <pc:chgData name="Weifeng Xu" userId="e7aed605-a3dd-4d5a-a692-a87037af107b" providerId="ADAL" clId="{5B9B619E-E5DC-4376-BCE8-41ABC28F6C2F}" dt="2021-06-28T19:40:27.003" v="18" actId="47"/>
-        <pc:sldMkLst>
-          <pc:docMk/>
-          <pc:sldMk cId="982174642" sldId="461"/>
-        </pc:sldMkLst>
-      </pc:sldChg>
-      <pc:sldChg chg="del">
-        <pc:chgData name="Weifeng Xu" userId="e7aed605-a3dd-4d5a-a692-a87037af107b" providerId="ADAL" clId="{5B9B619E-E5DC-4376-BCE8-41ABC28F6C2F}" dt="2021-06-28T19:40:22.278" v="6" actId="47"/>
-        <pc:sldMkLst>
-          <pc:docMk/>
-          <pc:sldMk cId="926730047" sldId="462"/>
-        </pc:sldMkLst>
-      </pc:sldChg>
-      <pc:sldChg chg="del">
-        <pc:chgData name="Weifeng Xu" userId="e7aed605-a3dd-4d5a-a692-a87037af107b" providerId="ADAL" clId="{5B9B619E-E5DC-4376-BCE8-41ABC28F6C2F}" dt="2021-06-28T19:40:24.346" v="16" actId="47"/>
-        <pc:sldMkLst>
-          <pc:docMk/>
-          <pc:sldMk cId="2128572627" sldId="463"/>
-        </pc:sldMkLst>
-      </pc:sldChg>
-      <pc:sldChg chg="del">
-        <pc:chgData name="Weifeng Xu" userId="e7aed605-a3dd-4d5a-a692-a87037af107b" providerId="ADAL" clId="{5B9B619E-E5DC-4376-BCE8-41ABC28F6C2F}" dt="2021-06-28T19:40:29.162" v="23" actId="47"/>
-        <pc:sldMkLst>
-          <pc:docMk/>
-          <pc:sldMk cId="3901806330" sldId="464"/>
-        </pc:sldMkLst>
-      </pc:sldChg>
-      <pc:sldChg chg="del">
-        <pc:chgData name="Weifeng Xu" userId="e7aed605-a3dd-4d5a-a692-a87037af107b" providerId="ADAL" clId="{5B9B619E-E5DC-4376-BCE8-41ABC28F6C2F}" dt="2021-06-28T19:40:28.042" v="19" actId="47"/>
-        <pc:sldMkLst>
-          <pc:docMk/>
-          <pc:sldMk cId="1673180284" sldId="465"/>
-        </pc:sldMkLst>
-      </pc:sldChg>
-      <pc:sldChg chg="del">
-        <pc:chgData name="Weifeng Xu" userId="e7aed605-a3dd-4d5a-a692-a87037af107b" providerId="ADAL" clId="{5B9B619E-E5DC-4376-BCE8-41ABC28F6C2F}" dt="2021-06-28T19:40:28.602" v="20" actId="47"/>
-        <pc:sldMkLst>
-          <pc:docMk/>
-          <pc:sldMk cId="369337190" sldId="466"/>
-        </pc:sldMkLst>
-      </pc:sldChg>
-      <pc:sldChg chg="add">
-        <pc:chgData name="Weifeng Xu" userId="e7aed605-a3dd-4d5a-a692-a87037af107b" providerId="ADAL" clId="{5B9B619E-E5DC-4376-BCE8-41ABC28F6C2F}" dt="2021-06-28T19:39:54.424" v="1"/>
-        <pc:sldMkLst>
-          <pc:docMk/>
-          <pc:sldMk cId="965843776" sldId="467"/>
-        </pc:sldMkLst>
-      </pc:sldChg>
-      <pc:sldChg chg="del">
-        <pc:chgData name="Weifeng Xu" userId="e7aed605-a3dd-4d5a-a692-a87037af107b" providerId="ADAL" clId="{5B9B619E-E5DC-4376-BCE8-41ABC28F6C2F}" dt="2021-06-28T19:40:29.322" v="24" actId="47"/>
-        <pc:sldMkLst>
-          <pc:docMk/>
-          <pc:sldMk cId="1544977207" sldId="468"/>
-        </pc:sldMkLst>
-      </pc:sldChg>
-      <pc:sldChg chg="del">
-        <pc:chgData name="Weifeng Xu" userId="e7aed605-a3dd-4d5a-a692-a87037af107b" providerId="ADAL" clId="{5B9B619E-E5DC-4376-BCE8-41ABC28F6C2F}" dt="2021-06-28T19:40:29.501" v="25" actId="47"/>
-        <pc:sldMkLst>
-          <pc:docMk/>
-          <pc:sldMk cId="3247576171" sldId="469"/>
-        </pc:sldMkLst>
-      </pc:sldChg>
-      <pc:sldChg chg="del">
-        <pc:chgData name="Weifeng Xu" userId="e7aed605-a3dd-4d5a-a692-a87037af107b" providerId="ADAL" clId="{5B9B619E-E5DC-4376-BCE8-41ABC28F6C2F}" dt="2021-06-28T19:40:29.865" v="27" actId="47"/>
-        <pc:sldMkLst>
-          <pc:docMk/>
-          <pc:sldMk cId="3121458959" sldId="470"/>
-        </pc:sldMkLst>
-      </pc:sldChg>
-      <pc:sldChg chg="del">
-        <pc:chgData name="Weifeng Xu" userId="e7aed605-a3dd-4d5a-a692-a87037af107b" providerId="ADAL" clId="{5B9B619E-E5DC-4376-BCE8-41ABC28F6C2F}" dt="2021-06-28T19:40:30.254" v="28" actId="47"/>
-        <pc:sldMkLst>
-          <pc:docMk/>
-          <pc:sldMk cId="2693326884" sldId="471"/>
-        </pc:sldMkLst>
-      </pc:sldChg>
-      <pc:sldChg chg="del">
-        <pc:chgData name="Weifeng Xu" userId="e7aed605-a3dd-4d5a-a692-a87037af107b" providerId="ADAL" clId="{5B9B619E-E5DC-4376-BCE8-41ABC28F6C2F}" dt="2021-06-28T19:40:30.263" v="29" actId="47"/>
-        <pc:sldMkLst>
-          <pc:docMk/>
-          <pc:sldMk cId="127914859" sldId="472"/>
-        </pc:sldMkLst>
-      </pc:sldChg>
-      <pc:sldChg chg="del">
-        <pc:chgData name="Weifeng Xu" userId="e7aed605-a3dd-4d5a-a692-a87037af107b" providerId="ADAL" clId="{5B9B619E-E5DC-4376-BCE8-41ABC28F6C2F}" dt="2021-06-28T19:40:31.073" v="32" actId="47"/>
-        <pc:sldMkLst>
-          <pc:docMk/>
-          <pc:sldMk cId="2516623109" sldId="475"/>
-        </pc:sldMkLst>
-      </pc:sldChg>
-      <pc:sldChg chg="del">
-        <pc:chgData name="Weifeng Xu" userId="e7aed605-a3dd-4d5a-a692-a87037af107b" providerId="ADAL" clId="{5B9B619E-E5DC-4376-BCE8-41ABC28F6C2F}" dt="2021-06-28T19:40:31.393" v="33" actId="47"/>
-        <pc:sldMkLst>
-          <pc:docMk/>
-          <pc:sldMk cId="3141623341" sldId="476"/>
-        </pc:sldMkLst>
-      </pc:sldChg>
-      <pc:sldChg chg="del">
-        <pc:chgData name="Weifeng Xu" userId="e7aed605-a3dd-4d5a-a692-a87037af107b" providerId="ADAL" clId="{5B9B619E-E5DC-4376-BCE8-41ABC28F6C2F}" dt="2021-06-28T19:40:31.714" v="34" actId="47"/>
-        <pc:sldMkLst>
-          <pc:docMk/>
-          <pc:sldMk cId="4107473677" sldId="477"/>
-        </pc:sldMkLst>
-      </pc:sldChg>
-      <pc:sldChg chg="del">
-        <pc:chgData name="Weifeng Xu" userId="e7aed605-a3dd-4d5a-a692-a87037af107b" providerId="ADAL" clId="{5B9B619E-E5DC-4376-BCE8-41ABC28F6C2F}" dt="2021-06-28T19:40:31.858" v="35" actId="47"/>
-        <pc:sldMkLst>
-          <pc:docMk/>
-          <pc:sldMk cId="1773530336" sldId="478"/>
-        </pc:sldMkLst>
-      </pc:sldChg>
-      <pc:sldChg chg="del">
-        <pc:chgData name="Weifeng Xu" userId="e7aed605-a3dd-4d5a-a692-a87037af107b" providerId="ADAL" clId="{5B9B619E-E5DC-4376-BCE8-41ABC28F6C2F}" dt="2021-06-28T19:40:34.221" v="42" actId="47"/>
-        <pc:sldMkLst>
-          <pc:docMk/>
-          <pc:sldMk cId="2418320045" sldId="481"/>
-        </pc:sldMkLst>
-      </pc:sldChg>
-      <pc:sldChg chg="del">
-        <pc:chgData name="Weifeng Xu" userId="e7aed605-a3dd-4d5a-a692-a87037af107b" providerId="ADAL" clId="{5B9B619E-E5DC-4376-BCE8-41ABC28F6C2F}" dt="2021-06-28T19:40:32.426" v="37" actId="47"/>
-        <pc:sldMkLst>
-          <pc:docMk/>
-          <pc:sldMk cId="1683867025" sldId="482"/>
-        </pc:sldMkLst>
-      </pc:sldChg>
-      <pc:sldChg chg="del">
-        <pc:chgData name="Weifeng Xu" userId="e7aed605-a3dd-4d5a-a692-a87037af107b" providerId="ADAL" clId="{5B9B619E-E5DC-4376-BCE8-41ABC28F6C2F}" dt="2021-06-28T19:40:32.693" v="38" actId="47"/>
-        <pc:sldMkLst>
-          <pc:docMk/>
-          <pc:sldMk cId="3022927922" sldId="484"/>
-        </pc:sldMkLst>
-      </pc:sldChg>
-      <pc:sldChg chg="del">
-        <pc:chgData name="Weifeng Xu" userId="e7aed605-a3dd-4d5a-a692-a87037af107b" providerId="ADAL" clId="{5B9B619E-E5DC-4376-BCE8-41ABC28F6C2F}" dt="2021-06-28T19:40:34.898" v="44" actId="47"/>
-        <pc:sldMkLst>
-          <pc:docMk/>
-          <pc:sldMk cId="1979037057" sldId="485"/>
-        </pc:sldMkLst>
-      </pc:sldChg>
-      <pc:sldChg chg="del">
-        <pc:chgData name="Weifeng Xu" userId="e7aed605-a3dd-4d5a-a692-a87037af107b" providerId="ADAL" clId="{5B9B619E-E5DC-4376-BCE8-41ABC28F6C2F}" dt="2021-06-28T19:40:35.185" v="45" actId="47"/>
-        <pc:sldMkLst>
-          <pc:docMk/>
-          <pc:sldMk cId="229412847" sldId="486"/>
-        </pc:sldMkLst>
-      </pc:sldChg>
-      <pc:sldChg chg="del">
-        <pc:chgData name="Weifeng Xu" userId="e7aed605-a3dd-4d5a-a692-a87037af107b" providerId="ADAL" clId="{5B9B619E-E5DC-4376-BCE8-41ABC28F6C2F}" dt="2021-06-28T19:40:35.713" v="46" actId="47"/>
-        <pc:sldMkLst>
-          <pc:docMk/>
-          <pc:sldMk cId="127162036" sldId="487"/>
-        </pc:sldMkLst>
-      </pc:sldChg>
-      <pc:sldChg chg="del">
-        <pc:chgData name="Weifeng Xu" userId="e7aed605-a3dd-4d5a-a692-a87037af107b" providerId="ADAL" clId="{5B9B619E-E5DC-4376-BCE8-41ABC28F6C2F}" dt="2021-06-28T19:40:36.169" v="47" actId="47"/>
-        <pc:sldMkLst>
-          <pc:docMk/>
-          <pc:sldMk cId="1436574554" sldId="488"/>
-        </pc:sldMkLst>
-      </pc:sldChg>
-      <pc:sldChg chg="del">
-        <pc:chgData name="Weifeng Xu" userId="e7aed605-a3dd-4d5a-a692-a87037af107b" providerId="ADAL" clId="{5B9B619E-E5DC-4376-BCE8-41ABC28F6C2F}" dt="2021-06-28T19:40:36.576" v="48" actId="47"/>
-        <pc:sldMkLst>
-          <pc:docMk/>
-          <pc:sldMk cId="3579863255" sldId="489"/>
-        </pc:sldMkLst>
-      </pc:sldChg>
-      <pc:sldChg chg="add">
-        <pc:chgData name="Weifeng Xu" userId="e7aed605-a3dd-4d5a-a692-a87037af107b" providerId="ADAL" clId="{5B9B619E-E5DC-4376-BCE8-41ABC28F6C2F}" dt="2021-06-28T19:39:54.424" v="1"/>
-        <pc:sldMkLst>
-          <pc:docMk/>
-          <pc:sldMk cId="1435293485" sldId="490"/>
-        </pc:sldMkLst>
-      </pc:sldChg>
-      <pc:sldChg chg="add">
-        <pc:chgData name="Weifeng Xu" userId="e7aed605-a3dd-4d5a-a692-a87037af107b" providerId="ADAL" clId="{5B9B619E-E5DC-4376-BCE8-41ABC28F6C2F}" dt="2021-06-28T19:39:54.424" v="1"/>
-        <pc:sldMkLst>
-          <pc:docMk/>
-          <pc:sldMk cId="3015196105" sldId="491"/>
-        </pc:sldMkLst>
-      </pc:sldChg>
-      <pc:sldChg chg="modSp add mod">
-        <pc:chgData name="Weifeng Xu" userId="e7aed605-a3dd-4d5a-a692-a87037af107b" providerId="ADAL" clId="{5B9B619E-E5DC-4376-BCE8-41ABC28F6C2F}" dt="2021-07-01T14:18:37.659" v="55" actId="6549"/>
-        <pc:sldMkLst>
-          <pc:docMk/>
-          <pc:sldMk cId="1674251011" sldId="492"/>
-        </pc:sldMkLst>
-      </pc:sldChg>
-      <pc:sldChg chg="add">
-        <pc:chgData name="Weifeng Xu" userId="e7aed605-a3dd-4d5a-a692-a87037af107b" providerId="ADAL" clId="{5B9B619E-E5DC-4376-BCE8-41ABC28F6C2F}" dt="2021-06-28T19:39:54.424" v="1"/>
-        <pc:sldMkLst>
-          <pc:docMk/>
-          <pc:sldMk cId="2416641626" sldId="493"/>
-        </pc:sldMkLst>
-      </pc:sldChg>
-      <pc:sldChg chg="add">
-        <pc:chgData name="Weifeng Xu" userId="e7aed605-a3dd-4d5a-a692-a87037af107b" providerId="ADAL" clId="{5B9B619E-E5DC-4376-BCE8-41ABC28F6C2F}" dt="2021-06-28T19:39:54.424" v="1"/>
-        <pc:sldMkLst>
-          <pc:docMk/>
-          <pc:sldMk cId="311612657" sldId="494"/>
-        </pc:sldMkLst>
-      </pc:sldChg>
-      <pc:sldChg chg="add">
-        <pc:chgData name="Weifeng Xu" userId="e7aed605-a3dd-4d5a-a692-a87037af107b" providerId="ADAL" clId="{5B9B619E-E5DC-4376-BCE8-41ABC28F6C2F}" dt="2021-06-28T19:39:54.424" v="1"/>
-        <pc:sldMkLst>
-          <pc:docMk/>
-          <pc:sldMk cId="3933795559" sldId="495"/>
-        </pc:sldMkLst>
-      </pc:sldChg>
-      <pc:sldChg chg="add">
-        <pc:chgData name="Weifeng Xu" userId="e7aed605-a3dd-4d5a-a692-a87037af107b" providerId="ADAL" clId="{5B9B619E-E5DC-4376-BCE8-41ABC28F6C2F}" dt="2021-06-28T19:39:54.424" v="1"/>
-        <pc:sldMkLst>
-          <pc:docMk/>
-          <pc:sldMk cId="684404787" sldId="496"/>
-        </pc:sldMkLst>
-      </pc:sldChg>
-      <pc:sldChg chg="add">
-        <pc:chgData name="Weifeng Xu" userId="e7aed605-a3dd-4d5a-a692-a87037af107b" providerId="ADAL" clId="{5B9B619E-E5DC-4376-BCE8-41ABC28F6C2F}" dt="2021-06-28T19:39:54.424" v="1"/>
-        <pc:sldMkLst>
-          <pc:docMk/>
-          <pc:sldMk cId="3211001472" sldId="497"/>
-        </pc:sldMkLst>
-      </pc:sldChg>
-      <pc:sldChg chg="add">
-        <pc:chgData name="Weifeng Xu" userId="e7aed605-a3dd-4d5a-a692-a87037af107b" providerId="ADAL" clId="{5B9B619E-E5DC-4376-BCE8-41ABC28F6C2F}" dt="2021-06-28T19:39:54.424" v="1"/>
-        <pc:sldMkLst>
-          <pc:docMk/>
-          <pc:sldMk cId="1035595462" sldId="498"/>
-        </pc:sldMkLst>
-      </pc:sldChg>
-      <pc:sldChg chg="add">
-        <pc:chgData name="Weifeng Xu" userId="e7aed605-a3dd-4d5a-a692-a87037af107b" providerId="ADAL" clId="{5B9B619E-E5DC-4376-BCE8-41ABC28F6C2F}" dt="2021-06-28T19:39:54.424" v="1"/>
-        <pc:sldMkLst>
-          <pc:docMk/>
-          <pc:sldMk cId="1984385075" sldId="499"/>
-        </pc:sldMkLst>
-      </pc:sldChg>
-      <pc:sldChg chg="add">
-        <pc:chgData name="Weifeng Xu" userId="e7aed605-a3dd-4d5a-a692-a87037af107b" providerId="ADAL" clId="{5B9B619E-E5DC-4376-BCE8-41ABC28F6C2F}" dt="2021-06-28T19:39:54.424" v="1"/>
-        <pc:sldMkLst>
-          <pc:docMk/>
-          <pc:sldMk cId="3318379012" sldId="500"/>
-        </pc:sldMkLst>
-      </pc:sldChg>
-      <pc:sldChg chg="add">
-        <pc:chgData name="Weifeng Xu" userId="e7aed605-a3dd-4d5a-a692-a87037af107b" providerId="ADAL" clId="{5B9B619E-E5DC-4376-BCE8-41ABC28F6C2F}" dt="2021-06-28T19:39:54.424" v="1"/>
-        <pc:sldMkLst>
-          <pc:docMk/>
-          <pc:sldMk cId="2125122821" sldId="501"/>
-        </pc:sldMkLst>
-      </pc:sldChg>
-      <pc:sldChg chg="add">
-        <pc:chgData name="Weifeng Xu" userId="e7aed605-a3dd-4d5a-a692-a87037af107b" providerId="ADAL" clId="{5B9B619E-E5DC-4376-BCE8-41ABC28F6C2F}" dt="2021-06-28T19:39:54.424" v="1"/>
-        <pc:sldMkLst>
-          <pc:docMk/>
-          <pc:sldMk cId="198983510" sldId="502"/>
-        </pc:sldMkLst>
-      </pc:sldChg>
-      <pc:sldChg chg="add">
-        <pc:chgData name="Weifeng Xu" userId="e7aed605-a3dd-4d5a-a692-a87037af107b" providerId="ADAL" clId="{5B9B619E-E5DC-4376-BCE8-41ABC28F6C2F}" dt="2021-06-28T19:39:54.424" v="1"/>
-        <pc:sldMkLst>
-          <pc:docMk/>
-          <pc:sldMk cId="686110812" sldId="503"/>
-        </pc:sldMkLst>
-      </pc:sldChg>
-      <pc:sldChg chg="add">
-        <pc:chgData name="Weifeng Xu" userId="e7aed605-a3dd-4d5a-a692-a87037af107b" providerId="ADAL" clId="{5B9B619E-E5DC-4376-BCE8-41ABC28F6C2F}" dt="2021-06-28T19:39:54.424" v="1"/>
-        <pc:sldMkLst>
-          <pc:docMk/>
-          <pc:sldMk cId="3430879985" sldId="504"/>
-        </pc:sldMkLst>
-      </pc:sldChg>
-      <pc:sldChg chg="add">
-        <pc:chgData name="Weifeng Xu" userId="e7aed605-a3dd-4d5a-a692-a87037af107b" providerId="ADAL" clId="{5B9B619E-E5DC-4376-BCE8-41ABC28F6C2F}" dt="2021-06-28T19:39:54.424" v="1"/>
-        <pc:sldMkLst>
-          <pc:docMk/>
-          <pc:sldMk cId="1270554279" sldId="505"/>
-        </pc:sldMkLst>
-      </pc:sldChg>
-      <pc:sldChg chg="add">
-        <pc:chgData name="Weifeng Xu" userId="e7aed605-a3dd-4d5a-a692-a87037af107b" providerId="ADAL" clId="{5B9B619E-E5DC-4376-BCE8-41ABC28F6C2F}" dt="2021-06-28T19:39:54.424" v="1"/>
-        <pc:sldMkLst>
-          <pc:docMk/>
-          <pc:sldMk cId="951356934" sldId="506"/>
-        </pc:sldMkLst>
-      </pc:sldChg>
-      <pc:sldChg chg="add">
-        <pc:chgData name="Weifeng Xu" userId="e7aed605-a3dd-4d5a-a692-a87037af107b" providerId="ADAL" clId="{5B9B619E-E5DC-4376-BCE8-41ABC28F6C2F}" dt="2021-06-28T19:39:54.424" v="1"/>
-        <pc:sldMkLst>
-          <pc:docMk/>
-          <pc:sldMk cId="1385115538" sldId="507"/>
-        </pc:sldMkLst>
-      </pc:sldChg>
-      <pc:sldChg chg="add">
-        <pc:chgData name="Weifeng Xu" userId="e7aed605-a3dd-4d5a-a692-a87037af107b" providerId="ADAL" clId="{5B9B619E-E5DC-4376-BCE8-41ABC28F6C2F}" dt="2021-06-28T19:39:54.424" v="1"/>
-        <pc:sldMkLst>
-          <pc:docMk/>
-          <pc:sldMk cId="494372939" sldId="508"/>
-        </pc:sldMkLst>
-      </pc:sldChg>
-      <pc:sldChg chg="add">
-        <pc:chgData name="Weifeng Xu" userId="e7aed605-a3dd-4d5a-a692-a87037af107b" providerId="ADAL" clId="{5B9B619E-E5DC-4376-BCE8-41ABC28F6C2F}" dt="2021-06-28T19:39:54.424" v="1"/>
-        <pc:sldMkLst>
-          <pc:docMk/>
-          <pc:sldMk cId="2058254067" sldId="509"/>
         </pc:sldMkLst>
       </pc:sldChg>
     </pc:docChg>
@@ -2612,7 +2612,7 @@
           <a:p>
             <a:fld id="{B9658D5F-65FB-4E17-9D5B-8CF1DE5A98DF}" type="datetimeFigureOut">
               <a:rPr lang="en-US" smtClean="0"/>
-              <a:t>2/12/2025</a:t>
+              <a:t>9/8/2026</a:t>
             </a:fld>
             <a:endParaRPr lang="en-US"/>
           </a:p>
@@ -2931,7 +2931,12 @@
               <a:rPr lang="fr-FR" dirty="0"/>
               <a:t>  -q https://raw.githubusercontent.com/frankwxu/digital-forensics-lab/main/Basic_Computer_Skills_for_Forensics/file_carving/usb_image/120M.7z</a:t>
             </a:r>
-            <a:endParaRPr lang="en-US" dirty="0"/>
+          </a:p>
+          <a:p>
+            <a:r>
+              <a:rPr lang="en-US" dirty="0"/>
+              <a:t>https://github.com/frankwxu/Digital-Forensics-Basic-Book/blob/main/files/120M.7z</a:t>
+            </a:r>
           </a:p>
         </p:txBody>
       </p:sp>
@@ -3100,7 +3105,7 @@
           <a:p>
             <a:fld id="{4263717A-E3C1-4BED-ABE0-B7069385E023}" type="datetimeFigureOut">
               <a:rPr lang="en-US" smtClean="0"/>
-              <a:t>2/12/2025</a:t>
+              <a:t>9/8/2026</a:t>
             </a:fld>
             <a:endParaRPr lang="en-US"/>
           </a:p>
@@ -3273,7 +3278,7 @@
           <a:p>
             <a:fld id="{4263717A-E3C1-4BED-ABE0-B7069385E023}" type="datetimeFigureOut">
               <a:rPr lang="en-US" smtClean="0"/>
-              <a:t>2/12/2025</a:t>
+              <a:t>9/8/2026</a:t>
             </a:fld>
             <a:endParaRPr lang="en-US"/>
           </a:p>
@@ -3451,7 +3456,7 @@
           <a:p>
             <a:fld id="{4263717A-E3C1-4BED-ABE0-B7069385E023}" type="datetimeFigureOut">
               <a:rPr lang="en-US" smtClean="0"/>
-              <a:t>2/12/2025</a:t>
+              <a:t>9/8/2026</a:t>
             </a:fld>
             <a:endParaRPr lang="en-US"/>
           </a:p>
@@ -3619,7 +3624,7 @@
           <a:p>
             <a:fld id="{4263717A-E3C1-4BED-ABE0-B7069385E023}" type="datetimeFigureOut">
               <a:rPr lang="en-US" smtClean="0"/>
-              <a:t>2/12/2025</a:t>
+              <a:t>9/8/2026</a:t>
             </a:fld>
             <a:endParaRPr lang="en-US"/>
           </a:p>
@@ -3864,7 +3869,7 @@
           <a:p>
             <a:fld id="{4263717A-E3C1-4BED-ABE0-B7069385E023}" type="datetimeFigureOut">
               <a:rPr lang="en-US" smtClean="0"/>
-              <a:t>2/12/2025</a:t>
+              <a:t>9/8/2026</a:t>
             </a:fld>
             <a:endParaRPr lang="en-US"/>
           </a:p>
@@ -4093,7 +4098,7 @@
           <a:p>
             <a:fld id="{4263717A-E3C1-4BED-ABE0-B7069385E023}" type="datetimeFigureOut">
               <a:rPr lang="en-US" smtClean="0"/>
-              <a:t>2/12/2025</a:t>
+              <a:t>9/8/2026</a:t>
             </a:fld>
             <a:endParaRPr lang="en-US"/>
           </a:p>
@@ -4457,7 +4462,7 @@
           <a:p>
             <a:fld id="{4263717A-E3C1-4BED-ABE0-B7069385E023}" type="datetimeFigureOut">
               <a:rPr lang="en-US" smtClean="0"/>
-              <a:t>2/12/2025</a:t>
+              <a:t>9/8/2026</a:t>
             </a:fld>
             <a:endParaRPr lang="en-US"/>
           </a:p>
@@ -4574,7 +4579,7 @@
           <a:p>
             <a:fld id="{4263717A-E3C1-4BED-ABE0-B7069385E023}" type="datetimeFigureOut">
               <a:rPr lang="en-US" smtClean="0"/>
-              <a:t>2/12/2025</a:t>
+              <a:t>9/8/2026</a:t>
             </a:fld>
             <a:endParaRPr lang="en-US"/>
           </a:p>
@@ -4669,7 +4674,7 @@
           <a:p>
             <a:fld id="{4263717A-E3C1-4BED-ABE0-B7069385E023}" type="datetimeFigureOut">
               <a:rPr lang="en-US" smtClean="0"/>
-              <a:t>2/12/2025</a:t>
+              <a:t>9/8/2026</a:t>
             </a:fld>
             <a:endParaRPr lang="en-US"/>
           </a:p>
@@ -4944,7 +4949,7 @@
           <a:p>
             <a:fld id="{4263717A-E3C1-4BED-ABE0-B7069385E023}" type="datetimeFigureOut">
               <a:rPr lang="en-US" smtClean="0"/>
-              <a:t>2/12/2025</a:t>
+              <a:t>9/8/2026</a:t>
             </a:fld>
             <a:endParaRPr lang="en-US"/>
           </a:p>
@@ -5196,7 +5201,7 @@
           <a:p>
             <a:fld id="{4263717A-E3C1-4BED-ABE0-B7069385E023}" type="datetimeFigureOut">
               <a:rPr lang="en-US" smtClean="0"/>
-              <a:t>2/12/2025</a:t>
+              <a:t>9/8/2026</a:t>
             </a:fld>
             <a:endParaRPr lang="en-US"/>
           </a:p>
@@ -5407,7 +5412,7 @@
           <a:p>
             <a:fld id="{4263717A-E3C1-4BED-ABE0-B7069385E023}" type="datetimeFigureOut">
               <a:rPr lang="en-US" smtClean="0"/>
-              <a:t>2/12/2025</a:t>
+              <a:t>9/8/2026</a:t>
             </a:fld>
             <a:endParaRPr lang="en-US"/>
           </a:p>
@@ -11167,20 +11172,15 @@
         </p:nvSpPr>
         <p:spPr/>
         <p:txBody>
-          <a:bodyPr/>
+          <a:bodyPr>
+            <a:normAutofit/>
+          </a:bodyPr>
           <a:lstStyle/>
           <a:p>
             <a:r>
               <a:rPr lang="en-GB" dirty="0"/>
-              <a:t>We have the image file </a:t>
-            </a:r>
-            <a:r>
-              <a:rPr lang="en-GB" dirty="0">
-                <a:hlinkClick r:id="rId2"/>
-              </a:rPr>
-              <a:t>https://raw.githubusercontent.com/frankwxu/digital-forensics-lab/main/Basic_Computer_Skills_for_Forensics/file_carving/usb_image/120M.7z</a:t>
-            </a:r>
-            <a:endParaRPr lang="en-GB" dirty="0"/>
+              <a:t>We have the image file https://raw.githubusercontent.com/frankwxu/Digital-Forensics-Basic-Book/main/files/120M.7z</a:t>
+            </a:r>
           </a:p>
           <a:p>
             <a:r>
@@ -11192,14 +11192,14 @@
             <a:pPr lvl="1"/>
             <a:r>
               <a:rPr lang="en-GB" dirty="0"/>
-              <a:t>Find all deleted files if there are any</a:t>
+              <a:t>Find all deleted files, if there are any</a:t>
             </a:r>
           </a:p>
           <a:p>
             <a:pPr lvl="1"/>
             <a:r>
               <a:rPr lang="en-GB" dirty="0"/>
-              <a:t>Find all phone numbers (using </a:t>
+              <a:t>Find all phone numbers (using a </a:t>
             </a:r>
             <a:r>
               <a:rPr lang="en-US" dirty="0"/>
@@ -11227,7 +11227,7 @@
             <a:pPr lvl="1"/>
             <a:r>
               <a:rPr lang="en-GB" dirty="0"/>
-              <a:t>explain of each command if you use commands</a:t>
+              <a:t>Explain each command if you use commands</a:t>
             </a:r>
           </a:p>
           <a:p>

</xml_diff>